<commit_message>
Apresentacao final: atualizacao manual de slides
</commit_message>
<xml_diff>
--- a/apresentacao_anfis_final.pptx
+++ b/apresentacao_anfis_final.pptx
@@ -5,29 +5,29 @@
     <p:sldMasterId id="2147483648" r:id="rId1"/>
   </p:sldMasterIdLst>
   <p:sldIdLst>
-    <p:sldId id="256" r:id="rId7"/>
-    <p:sldId id="257" r:id="rId8"/>
-    <p:sldId id="258" r:id="rId9"/>
-    <p:sldId id="259" r:id="rId10"/>
-    <p:sldId id="260" r:id="rId11"/>
-    <p:sldId id="261" r:id="rId12"/>
-    <p:sldId id="262" r:id="rId13"/>
-    <p:sldId id="263" r:id="rId14"/>
-    <p:sldId id="264" r:id="rId15"/>
-    <p:sldId id="265" r:id="rId16"/>
-    <p:sldId id="266" r:id="rId17"/>
-    <p:sldId id="267" r:id="rId18"/>
-    <p:sldId id="268" r:id="rId19"/>
-    <p:sldId id="269" r:id="rId20"/>
-    <p:sldId id="270" r:id="rId21"/>
-    <p:sldId id="271" r:id="rId22"/>
-    <p:sldId id="272" r:id="rId23"/>
-    <p:sldId id="273" r:id="rId24"/>
-    <p:sldId id="274" r:id="rId25"/>
-    <p:sldId id="275" r:id="rId26"/>
-    <p:sldId id="276" r:id="rId27"/>
+    <p:sldId id="256" r:id="rId2"/>
+    <p:sldId id="257" r:id="rId3"/>
+    <p:sldId id="258" r:id="rId4"/>
+    <p:sldId id="259" r:id="rId5"/>
+    <p:sldId id="260" r:id="rId6"/>
+    <p:sldId id="261" r:id="rId7"/>
+    <p:sldId id="262" r:id="rId8"/>
+    <p:sldId id="263" r:id="rId9"/>
+    <p:sldId id="264" r:id="rId10"/>
+    <p:sldId id="265" r:id="rId11"/>
+    <p:sldId id="266" r:id="rId12"/>
+    <p:sldId id="267" r:id="rId13"/>
+    <p:sldId id="268" r:id="rId14"/>
+    <p:sldId id="269" r:id="rId15"/>
+    <p:sldId id="270" r:id="rId16"/>
+    <p:sldId id="271" r:id="rId17"/>
+    <p:sldId id="272" r:id="rId18"/>
+    <p:sldId id="273" r:id="rId19"/>
+    <p:sldId id="274" r:id="rId20"/>
+    <p:sldId id="275" r:id="rId21"/>
+    <p:sldId id="276" r:id="rId22"/>
   </p:sldIdLst>
-  <p:sldSz cx="12188952" cy="6858000" type="screen4x3"/>
+  <p:sldSz cx="12188825" cy="6858000"/>
   <p:notesSz cx="6858000" cy="9144000"/>
   <p:defaultTextStyle>
     <a:defPPr>
@@ -124,7 +124,75 @@
       </a:defRPr>
     </a:lvl9pPr>
   </p:defaultTextStyle>
+  <p:extLst>
+    <p:ext uri="{EFAFB233-063F-42B5-8137-9DF3F51BA10A}">
+      <p15:sldGuideLst xmlns:p15="http://schemas.microsoft.com/office/powerpoint/2012/main">
+        <p15:guide id="1" orient="horz" pos="2160">
+          <p15:clr>
+            <a:srgbClr val="A4A3A4"/>
+          </p15:clr>
+        </p15:guide>
+        <p15:guide id="2" pos="2880">
+          <p15:clr>
+            <a:srgbClr val="A4A3A4"/>
+          </p15:clr>
+        </p15:guide>
+      </p15:sldGuideLst>
+    </p:ext>
+  </p:extLst>
 </p:presentation>
+</file>
+
+<file path=ppt/changesInfos/changesInfo1.xml><?xml version="1.0" encoding="utf-8"?>
+<pc:chgInfo xmlns:a="http://schemas.openxmlformats.org/drawingml/2006/main" xmlns:r="http://schemas.openxmlformats.org/officeDocument/2006/relationships" xmlns:ac="http://schemas.microsoft.com/office/drawing/2013/main/command" xmlns:pc="http://schemas.microsoft.com/office/powerpoint/2013/main/command">
+  <pc:docChgLst>
+    <pc:chgData name="Victor Bertini" userId="d993313d02d6d422" providerId="LiveId" clId="{458F1784-843B-461A-817F-C38F0F172C58}"/>
+    <pc:docChg chg="modSld">
+      <pc:chgData name="Victor Bertini" userId="d993313d02d6d422" providerId="LiveId" clId="{458F1784-843B-461A-817F-C38F0F172C58}" dt="2026-06-23T07:11:27.055" v="4" actId="1076"/>
+      <pc:docMkLst>
+        <pc:docMk/>
+      </pc:docMkLst>
+      <pc:sldChg chg="modSp mod">
+        <pc:chgData name="Victor Bertini" userId="d993313d02d6d422" providerId="LiveId" clId="{458F1784-843B-461A-817F-C38F0F172C58}" dt="2026-06-23T07:11:27.055" v="4" actId="1076"/>
+        <pc:sldMkLst>
+          <pc:docMk/>
+          <pc:sldMk cId="0" sldId="264"/>
+        </pc:sldMkLst>
+        <pc:spChg chg="mod">
+          <ac:chgData name="Victor Bertini" userId="d993313d02d6d422" providerId="LiveId" clId="{458F1784-843B-461A-817F-C38F0F172C58}" dt="2026-06-23T07:11:27.055" v="4" actId="1076"/>
+          <ac:spMkLst>
+            <pc:docMk/>
+            <pc:sldMk cId="0" sldId="264"/>
+            <ac:spMk id="7" creationId="{00000000-0000-0000-0000-000000000000}"/>
+          </ac:spMkLst>
+        </pc:spChg>
+        <pc:picChg chg="mod">
+          <ac:chgData name="Victor Bertini" userId="d993313d02d6d422" providerId="LiveId" clId="{458F1784-843B-461A-817F-C38F0F172C58}" dt="2026-06-23T07:11:18.981" v="1" actId="14100"/>
+          <ac:picMkLst>
+            <pc:docMk/>
+            <pc:sldMk cId="0" sldId="264"/>
+            <ac:picMk id="8" creationId="{00000000-0000-0000-0000-000000000000}"/>
+          </ac:picMkLst>
+        </pc:picChg>
+      </pc:sldChg>
+      <pc:sldChg chg="modSp mod">
+        <pc:chgData name="Victor Bertini" userId="d993313d02d6d422" providerId="LiveId" clId="{458F1784-843B-461A-817F-C38F0F172C58}" dt="2026-06-23T07:10:03.305" v="0" actId="14100"/>
+        <pc:sldMkLst>
+          <pc:docMk/>
+          <pc:sldMk cId="0" sldId="272"/>
+        </pc:sldMkLst>
+        <pc:picChg chg="mod">
+          <ac:chgData name="Victor Bertini" userId="d993313d02d6d422" providerId="LiveId" clId="{458F1784-843B-461A-817F-C38F0F172C58}" dt="2026-06-23T07:10:03.305" v="0" actId="14100"/>
+          <ac:picMkLst>
+            <pc:docMk/>
+            <pc:sldMk cId="0" sldId="272"/>
+            <ac:picMk id="11" creationId="{00000000-0000-0000-0000-000000000000}"/>
+          </ac:picMkLst>
+        </pc:picChg>
+      </pc:sldChg>
+    </pc:docChg>
+  </pc:docChgLst>
+</pc:chgInfo>
 </file>
 
 <file path=ppt/slideLayouts/slideLayout1.xml><?xml version="1.0" encoding="utf-8"?>
@@ -165,10 +233,9 @@
           <a:lstStyle/>
           <a:p>
             <a:r>
-              <a:rPr lang="en-US" smtClean="0"/>
+              <a:rPr lang="en-US"/>
               <a:t>Click to edit Master title style</a:t>
             </a:r>
-            <a:endParaRPr lang="en-US"/>
           </a:p>
         </p:txBody>
       </p:sp>
@@ -284,10 +351,9 @@
           </a:lstStyle>
           <a:p>
             <a:r>
-              <a:rPr lang="en-US" smtClean="0"/>
+              <a:rPr lang="en-US"/>
               <a:t>Click to edit Master subtitle style</a:t>
             </a:r>
-            <a:endParaRPr lang="en-US"/>
           </a:p>
         </p:txBody>
       </p:sp>
@@ -308,7 +374,7 @@
           <a:p>
             <a:fld id="{5BCAD085-E8A6-8845-BD4E-CB4CCA059FC4}" type="datetimeFigureOut">
               <a:rPr lang="en-US" smtClean="0"/>
-              <a:t>1/27/13</a:t>
+              <a:t>6/23/2026</a:t>
             </a:fld>
             <a:endParaRPr lang="en-US"/>
           </a:p>
@@ -402,10 +468,9 @@
           <a:lstStyle/>
           <a:p>
             <a:r>
-              <a:rPr lang="en-US" smtClean="0"/>
+              <a:rPr lang="en-US"/>
               <a:t>Click to edit Master title style</a:t>
             </a:r>
-            <a:endParaRPr lang="en-US"/>
           </a:p>
         </p:txBody>
       </p:sp>
@@ -426,38 +491,37 @@
           <a:p>
             <a:pPr lvl="0"/>
             <a:r>
-              <a:rPr lang="en-US" smtClean="0"/>
+              <a:rPr lang="en-US"/>
               <a:t>Click to edit Master text styles</a:t>
             </a:r>
           </a:p>
           <a:p>
             <a:pPr lvl="1"/>
             <a:r>
-              <a:rPr lang="en-US" smtClean="0"/>
+              <a:rPr lang="en-US"/>
               <a:t>Second level</a:t>
             </a:r>
           </a:p>
           <a:p>
             <a:pPr lvl="2"/>
             <a:r>
-              <a:rPr lang="en-US" smtClean="0"/>
+              <a:rPr lang="en-US"/>
               <a:t>Third level</a:t>
             </a:r>
           </a:p>
           <a:p>
             <a:pPr lvl="3"/>
             <a:r>
-              <a:rPr lang="en-US" smtClean="0"/>
+              <a:rPr lang="en-US"/>
               <a:t>Fourth level</a:t>
             </a:r>
           </a:p>
           <a:p>
             <a:pPr lvl="4"/>
             <a:r>
-              <a:rPr lang="en-US" smtClean="0"/>
+              <a:rPr lang="en-US"/>
               <a:t>Fifth level</a:t>
             </a:r>
-            <a:endParaRPr lang="en-US"/>
           </a:p>
         </p:txBody>
       </p:sp>
@@ -478,7 +542,7 @@
           <a:p>
             <a:fld id="{5BCAD085-E8A6-8845-BD4E-CB4CCA059FC4}" type="datetimeFigureOut">
               <a:rPr lang="en-US" smtClean="0"/>
-              <a:t>1/27/13</a:t>
+              <a:t>6/23/2026</a:t>
             </a:fld>
             <a:endParaRPr lang="en-US"/>
           </a:p>
@@ -577,10 +641,9 @@
           <a:lstStyle/>
           <a:p>
             <a:r>
-              <a:rPr lang="en-US" smtClean="0"/>
+              <a:rPr lang="en-US"/>
               <a:t>Click to edit Master title style</a:t>
             </a:r>
-            <a:endParaRPr lang="en-US"/>
           </a:p>
         </p:txBody>
       </p:sp>
@@ -606,38 +669,37 @@
           <a:p>
             <a:pPr lvl="0"/>
             <a:r>
-              <a:rPr lang="en-US" smtClean="0"/>
+              <a:rPr lang="en-US"/>
               <a:t>Click to edit Master text styles</a:t>
             </a:r>
           </a:p>
           <a:p>
             <a:pPr lvl="1"/>
             <a:r>
-              <a:rPr lang="en-US" smtClean="0"/>
+              <a:rPr lang="en-US"/>
               <a:t>Second level</a:t>
             </a:r>
           </a:p>
           <a:p>
             <a:pPr lvl="2"/>
             <a:r>
-              <a:rPr lang="en-US" smtClean="0"/>
+              <a:rPr lang="en-US"/>
               <a:t>Third level</a:t>
             </a:r>
           </a:p>
           <a:p>
             <a:pPr lvl="3"/>
             <a:r>
-              <a:rPr lang="en-US" smtClean="0"/>
+              <a:rPr lang="en-US"/>
               <a:t>Fourth level</a:t>
             </a:r>
           </a:p>
           <a:p>
             <a:pPr lvl="4"/>
             <a:r>
-              <a:rPr lang="en-US" smtClean="0"/>
+              <a:rPr lang="en-US"/>
               <a:t>Fifth level</a:t>
             </a:r>
-            <a:endParaRPr lang="en-US"/>
           </a:p>
         </p:txBody>
       </p:sp>
@@ -658,7 +720,7 @@
           <a:p>
             <a:fld id="{5BCAD085-E8A6-8845-BD4E-CB4CCA059FC4}" type="datetimeFigureOut">
               <a:rPr lang="en-US" smtClean="0"/>
-              <a:t>1/27/13</a:t>
+              <a:t>6/23/2026</a:t>
             </a:fld>
             <a:endParaRPr lang="en-US"/>
           </a:p>
@@ -752,10 +814,9 @@
           <a:lstStyle/>
           <a:p>
             <a:r>
-              <a:rPr lang="en-US" smtClean="0"/>
+              <a:rPr lang="en-US"/>
               <a:t>Click to edit Master title style</a:t>
             </a:r>
-            <a:endParaRPr lang="en-US"/>
           </a:p>
         </p:txBody>
       </p:sp>
@@ -776,38 +837,37 @@
           <a:p>
             <a:pPr lvl="0"/>
             <a:r>
-              <a:rPr lang="en-US" smtClean="0"/>
+              <a:rPr lang="en-US"/>
               <a:t>Click to edit Master text styles</a:t>
             </a:r>
           </a:p>
           <a:p>
             <a:pPr lvl="1"/>
             <a:r>
-              <a:rPr lang="en-US" smtClean="0"/>
+              <a:rPr lang="en-US"/>
               <a:t>Second level</a:t>
             </a:r>
           </a:p>
           <a:p>
             <a:pPr lvl="2"/>
             <a:r>
-              <a:rPr lang="en-US" smtClean="0"/>
+              <a:rPr lang="en-US"/>
               <a:t>Third level</a:t>
             </a:r>
           </a:p>
           <a:p>
             <a:pPr lvl="3"/>
             <a:r>
-              <a:rPr lang="en-US" smtClean="0"/>
+              <a:rPr lang="en-US"/>
               <a:t>Fourth level</a:t>
             </a:r>
           </a:p>
           <a:p>
             <a:pPr lvl="4"/>
             <a:r>
-              <a:rPr lang="en-US" smtClean="0"/>
+              <a:rPr lang="en-US"/>
               <a:t>Fifth level</a:t>
             </a:r>
-            <a:endParaRPr lang="en-US"/>
           </a:p>
         </p:txBody>
       </p:sp>
@@ -828,7 +888,7 @@
           <a:p>
             <a:fld id="{5BCAD085-E8A6-8845-BD4E-CB4CCA059FC4}" type="datetimeFigureOut">
               <a:rPr lang="en-US" smtClean="0"/>
-              <a:t>1/27/13</a:t>
+              <a:t>6/23/2026</a:t>
             </a:fld>
             <a:endParaRPr lang="en-US"/>
           </a:p>
@@ -931,10 +991,9 @@
           </a:lstStyle>
           <a:p>
             <a:r>
-              <a:rPr lang="en-US" smtClean="0"/>
+              <a:rPr lang="en-US"/>
               <a:t>Click to edit Master title style</a:t>
             </a:r>
-            <a:endParaRPr lang="en-US"/>
           </a:p>
         </p:txBody>
       </p:sp>
@@ -1051,7 +1110,7 @@
           <a:p>
             <a:pPr lvl="0"/>
             <a:r>
-              <a:rPr lang="en-US" smtClean="0"/>
+              <a:rPr lang="en-US"/>
               <a:t>Click to edit Master text styles</a:t>
             </a:r>
           </a:p>
@@ -1074,7 +1133,7 @@
           <a:p>
             <a:fld id="{5BCAD085-E8A6-8845-BD4E-CB4CCA059FC4}" type="datetimeFigureOut">
               <a:rPr lang="en-US" smtClean="0"/>
-              <a:t>1/27/13</a:t>
+              <a:t>6/23/2026</a:t>
             </a:fld>
             <a:endParaRPr lang="en-US"/>
           </a:p>
@@ -1168,10 +1227,9 @@
           <a:lstStyle/>
           <a:p>
             <a:r>
-              <a:rPr lang="en-US" smtClean="0"/>
+              <a:rPr lang="en-US"/>
               <a:t>Click to edit Master title style</a:t>
             </a:r>
-            <a:endParaRPr lang="en-US"/>
           </a:p>
         </p:txBody>
       </p:sp>
@@ -1225,38 +1283,37 @@
           <a:p>
             <a:pPr lvl="0"/>
             <a:r>
-              <a:rPr lang="en-US" smtClean="0"/>
+              <a:rPr lang="en-US"/>
               <a:t>Click to edit Master text styles</a:t>
             </a:r>
           </a:p>
           <a:p>
             <a:pPr lvl="1"/>
             <a:r>
-              <a:rPr lang="en-US" smtClean="0"/>
+              <a:rPr lang="en-US"/>
               <a:t>Second level</a:t>
             </a:r>
           </a:p>
           <a:p>
             <a:pPr lvl="2"/>
             <a:r>
-              <a:rPr lang="en-US" smtClean="0"/>
+              <a:rPr lang="en-US"/>
               <a:t>Third level</a:t>
             </a:r>
           </a:p>
           <a:p>
             <a:pPr lvl="3"/>
             <a:r>
-              <a:rPr lang="en-US" smtClean="0"/>
+              <a:rPr lang="en-US"/>
               <a:t>Fourth level</a:t>
             </a:r>
           </a:p>
           <a:p>
             <a:pPr lvl="4"/>
             <a:r>
-              <a:rPr lang="en-US" smtClean="0"/>
+              <a:rPr lang="en-US"/>
               <a:t>Fifth level</a:t>
             </a:r>
-            <a:endParaRPr lang="en-US"/>
           </a:p>
         </p:txBody>
       </p:sp>
@@ -1310,38 +1367,37 @@
           <a:p>
             <a:pPr lvl="0"/>
             <a:r>
-              <a:rPr lang="en-US" smtClean="0"/>
+              <a:rPr lang="en-US"/>
               <a:t>Click to edit Master text styles</a:t>
             </a:r>
           </a:p>
           <a:p>
             <a:pPr lvl="1"/>
             <a:r>
-              <a:rPr lang="en-US" smtClean="0"/>
+              <a:rPr lang="en-US"/>
               <a:t>Second level</a:t>
             </a:r>
           </a:p>
           <a:p>
             <a:pPr lvl="2"/>
             <a:r>
-              <a:rPr lang="en-US" smtClean="0"/>
+              <a:rPr lang="en-US"/>
               <a:t>Third level</a:t>
             </a:r>
           </a:p>
           <a:p>
             <a:pPr lvl="3"/>
             <a:r>
-              <a:rPr lang="en-US" smtClean="0"/>
+              <a:rPr lang="en-US"/>
               <a:t>Fourth level</a:t>
             </a:r>
           </a:p>
           <a:p>
             <a:pPr lvl="4"/>
             <a:r>
-              <a:rPr lang="en-US" smtClean="0"/>
+              <a:rPr lang="en-US"/>
               <a:t>Fifth level</a:t>
             </a:r>
-            <a:endParaRPr lang="en-US"/>
           </a:p>
         </p:txBody>
       </p:sp>
@@ -1362,7 +1418,7 @@
           <a:p>
             <a:fld id="{5BCAD085-E8A6-8845-BD4E-CB4CCA059FC4}" type="datetimeFigureOut">
               <a:rPr lang="en-US" smtClean="0"/>
-              <a:t>1/27/13</a:t>
+              <a:t>6/23/2026</a:t>
             </a:fld>
             <a:endParaRPr lang="en-US"/>
           </a:p>
@@ -1460,10 +1516,9 @@
           </a:lstStyle>
           <a:p>
             <a:r>
-              <a:rPr lang="en-US" smtClean="0"/>
+              <a:rPr lang="en-US"/>
               <a:t>Click to edit Master title style</a:t>
             </a:r>
-            <a:endParaRPr lang="en-US"/>
           </a:p>
         </p:txBody>
       </p:sp>
@@ -1526,7 +1581,7 @@
           <a:p>
             <a:pPr lvl="0"/>
             <a:r>
-              <a:rPr lang="en-US" smtClean="0"/>
+              <a:rPr lang="en-US"/>
               <a:t>Click to edit Master text styles</a:t>
             </a:r>
           </a:p>
@@ -1582,38 +1637,37 @@
           <a:p>
             <a:pPr lvl="0"/>
             <a:r>
-              <a:rPr lang="en-US" smtClean="0"/>
+              <a:rPr lang="en-US"/>
               <a:t>Click to edit Master text styles</a:t>
             </a:r>
           </a:p>
           <a:p>
             <a:pPr lvl="1"/>
             <a:r>
-              <a:rPr lang="en-US" smtClean="0"/>
+              <a:rPr lang="en-US"/>
               <a:t>Second level</a:t>
             </a:r>
           </a:p>
           <a:p>
             <a:pPr lvl="2"/>
             <a:r>
-              <a:rPr lang="en-US" smtClean="0"/>
+              <a:rPr lang="en-US"/>
               <a:t>Third level</a:t>
             </a:r>
           </a:p>
           <a:p>
             <a:pPr lvl="3"/>
             <a:r>
-              <a:rPr lang="en-US" smtClean="0"/>
+              <a:rPr lang="en-US"/>
               <a:t>Fourth level</a:t>
             </a:r>
           </a:p>
           <a:p>
             <a:pPr lvl="4"/>
             <a:r>
-              <a:rPr lang="en-US" smtClean="0"/>
+              <a:rPr lang="en-US"/>
               <a:t>Fifth level</a:t>
             </a:r>
-            <a:endParaRPr lang="en-US"/>
           </a:p>
         </p:txBody>
       </p:sp>
@@ -1676,7 +1730,7 @@
           <a:p>
             <a:pPr lvl="0"/>
             <a:r>
-              <a:rPr lang="en-US" smtClean="0"/>
+              <a:rPr lang="en-US"/>
               <a:t>Click to edit Master text styles</a:t>
             </a:r>
           </a:p>
@@ -1732,38 +1786,37 @@
           <a:p>
             <a:pPr lvl="0"/>
             <a:r>
-              <a:rPr lang="en-US" smtClean="0"/>
+              <a:rPr lang="en-US"/>
               <a:t>Click to edit Master text styles</a:t>
             </a:r>
           </a:p>
           <a:p>
             <a:pPr lvl="1"/>
             <a:r>
-              <a:rPr lang="en-US" smtClean="0"/>
+              <a:rPr lang="en-US"/>
               <a:t>Second level</a:t>
             </a:r>
           </a:p>
           <a:p>
             <a:pPr lvl="2"/>
             <a:r>
-              <a:rPr lang="en-US" smtClean="0"/>
+              <a:rPr lang="en-US"/>
               <a:t>Third level</a:t>
             </a:r>
           </a:p>
           <a:p>
             <a:pPr lvl="3"/>
             <a:r>
-              <a:rPr lang="en-US" smtClean="0"/>
+              <a:rPr lang="en-US"/>
               <a:t>Fourth level</a:t>
             </a:r>
           </a:p>
           <a:p>
             <a:pPr lvl="4"/>
             <a:r>
-              <a:rPr lang="en-US" smtClean="0"/>
+              <a:rPr lang="en-US"/>
               <a:t>Fifth level</a:t>
             </a:r>
-            <a:endParaRPr lang="en-US"/>
           </a:p>
         </p:txBody>
       </p:sp>
@@ -1784,7 +1837,7 @@
           <a:p>
             <a:fld id="{5BCAD085-E8A6-8845-BD4E-CB4CCA059FC4}" type="datetimeFigureOut">
               <a:rPr lang="en-US" smtClean="0"/>
-              <a:t>1/27/13</a:t>
+              <a:t>6/23/2026</a:t>
             </a:fld>
             <a:endParaRPr lang="en-US"/>
           </a:p>
@@ -1878,10 +1931,9 @@
           <a:lstStyle/>
           <a:p>
             <a:r>
-              <a:rPr lang="en-US" smtClean="0"/>
+              <a:rPr lang="en-US"/>
               <a:t>Click to edit Master title style</a:t>
             </a:r>
-            <a:endParaRPr lang="en-US"/>
           </a:p>
         </p:txBody>
       </p:sp>
@@ -1902,7 +1954,7 @@
           <a:p>
             <a:fld id="{5BCAD085-E8A6-8845-BD4E-CB4CCA059FC4}" type="datetimeFigureOut">
               <a:rPr lang="en-US" smtClean="0"/>
-              <a:t>1/27/13</a:t>
+              <a:t>6/23/2026</a:t>
             </a:fld>
             <a:endParaRPr lang="en-US"/>
           </a:p>
@@ -1997,7 +2049,7 @@
           <a:p>
             <a:fld id="{5BCAD085-E8A6-8845-BD4E-CB4CCA059FC4}" type="datetimeFigureOut">
               <a:rPr lang="en-US" smtClean="0"/>
-              <a:t>1/27/13</a:t>
+              <a:t>6/23/2026</a:t>
             </a:fld>
             <a:endParaRPr lang="en-US"/>
           </a:p>
@@ -2100,10 +2152,9 @@
           </a:lstStyle>
           <a:p>
             <a:r>
-              <a:rPr lang="en-US" smtClean="0"/>
+              <a:rPr lang="en-US"/>
               <a:t>Click to edit Master title style</a:t>
             </a:r>
-            <a:endParaRPr lang="en-US"/>
           </a:p>
         </p:txBody>
       </p:sp>
@@ -2157,38 +2208,37 @@
           <a:p>
             <a:pPr lvl="0"/>
             <a:r>
-              <a:rPr lang="en-US" smtClean="0"/>
+              <a:rPr lang="en-US"/>
               <a:t>Click to edit Master text styles</a:t>
             </a:r>
           </a:p>
           <a:p>
             <a:pPr lvl="1"/>
             <a:r>
-              <a:rPr lang="en-US" smtClean="0"/>
+              <a:rPr lang="en-US"/>
               <a:t>Second level</a:t>
             </a:r>
           </a:p>
           <a:p>
             <a:pPr lvl="2"/>
             <a:r>
-              <a:rPr lang="en-US" smtClean="0"/>
+              <a:rPr lang="en-US"/>
               <a:t>Third level</a:t>
             </a:r>
           </a:p>
           <a:p>
             <a:pPr lvl="3"/>
             <a:r>
-              <a:rPr lang="en-US" smtClean="0"/>
+              <a:rPr lang="en-US"/>
               <a:t>Fourth level</a:t>
             </a:r>
           </a:p>
           <a:p>
             <a:pPr lvl="4"/>
             <a:r>
-              <a:rPr lang="en-US" smtClean="0"/>
+              <a:rPr lang="en-US"/>
               <a:t>Fifth level</a:t>
             </a:r>
-            <a:endParaRPr lang="en-US"/>
           </a:p>
         </p:txBody>
       </p:sp>
@@ -2251,7 +2301,7 @@
           <a:p>
             <a:pPr lvl="0"/>
             <a:r>
-              <a:rPr lang="en-US" smtClean="0"/>
+              <a:rPr lang="en-US"/>
               <a:t>Click to edit Master text styles</a:t>
             </a:r>
           </a:p>
@@ -2274,7 +2324,7 @@
           <a:p>
             <a:fld id="{5BCAD085-E8A6-8845-BD4E-CB4CCA059FC4}" type="datetimeFigureOut">
               <a:rPr lang="en-US" smtClean="0"/>
-              <a:t>1/27/13</a:t>
+              <a:t>6/23/2026</a:t>
             </a:fld>
             <a:endParaRPr lang="en-US"/>
           </a:p>
@@ -2377,10 +2427,9 @@
           </a:lstStyle>
           <a:p>
             <a:r>
-              <a:rPr lang="en-US" smtClean="0"/>
+              <a:rPr lang="en-US"/>
               <a:t>Click to edit Master title style</a:t>
             </a:r>
-            <a:endParaRPr lang="en-US"/>
           </a:p>
         </p:txBody>
       </p:sp>
@@ -2504,7 +2553,7 @@
           <a:p>
             <a:pPr lvl="0"/>
             <a:r>
-              <a:rPr lang="en-US" smtClean="0"/>
+              <a:rPr lang="en-US"/>
               <a:t>Click to edit Master text styles</a:t>
             </a:r>
           </a:p>
@@ -2527,7 +2576,7 @@
           <a:p>
             <a:fld id="{5BCAD085-E8A6-8845-BD4E-CB4CCA059FC4}" type="datetimeFigureOut">
               <a:rPr lang="en-US" smtClean="0"/>
-              <a:t>1/27/13</a:t>
+              <a:t>6/23/2026</a:t>
             </a:fld>
             <a:endParaRPr lang="en-US"/>
           </a:p>
@@ -2636,10 +2685,9 @@
           <a:lstStyle/>
           <a:p>
             <a:r>
-              <a:rPr lang="en-US" smtClean="0"/>
+              <a:rPr lang="en-US"/>
               <a:t>Click to edit Master title style</a:t>
             </a:r>
-            <a:endParaRPr lang="en-US"/>
           </a:p>
         </p:txBody>
       </p:sp>
@@ -2670,38 +2718,37 @@
           <a:p>
             <a:pPr lvl="0"/>
             <a:r>
-              <a:rPr lang="en-US" smtClean="0"/>
+              <a:rPr lang="en-US"/>
               <a:t>Click to edit Master text styles</a:t>
             </a:r>
           </a:p>
           <a:p>
             <a:pPr lvl="1"/>
             <a:r>
-              <a:rPr lang="en-US" smtClean="0"/>
+              <a:rPr lang="en-US"/>
               <a:t>Second level</a:t>
             </a:r>
           </a:p>
           <a:p>
             <a:pPr lvl="2"/>
             <a:r>
-              <a:rPr lang="en-US" smtClean="0"/>
+              <a:rPr lang="en-US"/>
               <a:t>Third level</a:t>
             </a:r>
           </a:p>
           <a:p>
             <a:pPr lvl="3"/>
             <a:r>
-              <a:rPr lang="en-US" smtClean="0"/>
+              <a:rPr lang="en-US"/>
               <a:t>Fourth level</a:t>
             </a:r>
           </a:p>
           <a:p>
             <a:pPr lvl="4"/>
             <a:r>
-              <a:rPr lang="en-US" smtClean="0"/>
+              <a:rPr lang="en-US"/>
               <a:t>Fifth level</a:t>
             </a:r>
-            <a:endParaRPr lang="en-US"/>
           </a:p>
         </p:txBody>
       </p:sp>
@@ -2740,7 +2787,7 @@
           <a:p>
             <a:fld id="{5BCAD085-E8A6-8845-BD4E-CB4CCA059FC4}" type="datetimeFigureOut">
               <a:rPr lang="en-US" smtClean="0"/>
-              <a:t>1/27/13</a:t>
+              <a:t>6/23/2026</a:t>
             </a:fld>
             <a:endParaRPr lang="en-US"/>
           </a:p>
@@ -3099,7 +3146,7 @@
 </file>
 
 <file path=ppt/slides/slide1.xml><?xml version="1.0" encoding="utf-8"?>
-<p:sld xmlns:a="http://schemas.openxmlformats.org/drawingml/2006/main" xmlns:p="http://schemas.openxmlformats.org/presentationml/2006/main" xmlns:r="http://schemas.openxmlformats.org/officeDocument/2006/relationships">
+<p:sld xmlns:a="http://schemas.openxmlformats.org/drawingml/2006/main" xmlns:r="http://schemas.openxmlformats.org/officeDocument/2006/relationships" xmlns:p="http://schemas.openxmlformats.org/presentationml/2006/main">
   <p:cSld>
     <p:spTree>
       <p:nvGrpSpPr>
@@ -3107,7 +3154,14 @@
         <p:cNvGrpSpPr/>
         <p:nvPr/>
       </p:nvGrpSpPr>
-      <p:grpSpPr/>
+      <p:grpSpPr>
+        <a:xfrm>
+          <a:off x="0" y="0"/>
+          <a:ext cx="0" cy="0"/>
+          <a:chOff x="0" y="0"/>
+          <a:chExt cx="0" cy="0"/>
+        </a:xfrm>
+      </p:grpSpPr>
       <p:sp>
         <p:nvSpPr>
           <p:cNvPr id="2" name="Rectangle 1"/>
@@ -3148,6 +3202,7 @@
           <a:lstStyle/>
           <a:p>
             <a:pPr algn="ctr"/>
+            <a:endParaRPr/>
           </a:p>
         </p:txBody>
       </p:sp>
@@ -3191,6 +3246,7 @@
           <a:lstStyle/>
           <a:p>
             <a:pPr algn="ctr"/>
+            <a:endParaRPr/>
           </a:p>
         </p:txBody>
       </p:sp>
@@ -3258,6 +3314,7 @@
           <a:lstStyle/>
           <a:p>
             <a:pPr algn="ctr"/>
+            <a:endParaRPr/>
           </a:p>
         </p:txBody>
       </p:sp>
@@ -3301,6 +3358,7 @@
           <a:lstStyle/>
           <a:p>
             <a:pPr algn="ctr"/>
+            <a:endParaRPr/>
           </a:p>
         </p:txBody>
       </p:sp>
@@ -3415,7 +3473,7 @@
 </file>
 
 <file path=ppt/slides/slide10.xml><?xml version="1.0" encoding="utf-8"?>
-<p:sld xmlns:a="http://schemas.openxmlformats.org/drawingml/2006/main" xmlns:p="http://schemas.openxmlformats.org/presentationml/2006/main" xmlns:r="http://schemas.openxmlformats.org/officeDocument/2006/relationships">
+<p:sld xmlns:a="http://schemas.openxmlformats.org/drawingml/2006/main" xmlns:r="http://schemas.openxmlformats.org/officeDocument/2006/relationships" xmlns:p="http://schemas.openxmlformats.org/presentationml/2006/main">
   <p:cSld>
     <p:spTree>
       <p:nvGrpSpPr>
@@ -3423,7 +3481,14 @@
         <p:cNvGrpSpPr/>
         <p:nvPr/>
       </p:nvGrpSpPr>
-      <p:grpSpPr/>
+      <p:grpSpPr>
+        <a:xfrm>
+          <a:off x="0" y="0"/>
+          <a:ext cx="0" cy="0"/>
+          <a:chOff x="0" y="0"/>
+          <a:chExt cx="0" cy="0"/>
+        </a:xfrm>
+      </p:grpSpPr>
       <p:sp>
         <p:nvSpPr>
           <p:cNvPr id="2" name="Rectangle 1"/>
@@ -3464,6 +3529,7 @@
           <a:lstStyle/>
           <a:p>
             <a:pPr algn="ctr"/>
+            <a:endParaRPr/>
           </a:p>
         </p:txBody>
       </p:sp>
@@ -3565,6 +3631,7 @@
           <a:lstStyle/>
           <a:p>
             <a:pPr algn="ctr"/>
+            <a:endParaRPr/>
           </a:p>
         </p:txBody>
       </p:sp>
@@ -4612,7 +4679,7 @@
 </file>
 
 <file path=ppt/slides/slide11.xml><?xml version="1.0" encoding="utf-8"?>
-<p:sld xmlns:a="http://schemas.openxmlformats.org/drawingml/2006/main" xmlns:p="http://schemas.openxmlformats.org/presentationml/2006/main" xmlns:r="http://schemas.openxmlformats.org/officeDocument/2006/relationships">
+<p:sld xmlns:a="http://schemas.openxmlformats.org/drawingml/2006/main" xmlns:r="http://schemas.openxmlformats.org/officeDocument/2006/relationships" xmlns:p="http://schemas.openxmlformats.org/presentationml/2006/main">
   <p:cSld>
     <p:spTree>
       <p:nvGrpSpPr>
@@ -4620,7 +4687,14 @@
         <p:cNvGrpSpPr/>
         <p:nvPr/>
       </p:nvGrpSpPr>
-      <p:grpSpPr/>
+      <p:grpSpPr>
+        <a:xfrm>
+          <a:off x="0" y="0"/>
+          <a:ext cx="0" cy="0"/>
+          <a:chOff x="0" y="0"/>
+          <a:chExt cx="0" cy="0"/>
+        </a:xfrm>
+      </p:grpSpPr>
       <p:sp>
         <p:nvSpPr>
           <p:cNvPr id="2" name="Rectangle 1"/>
@@ -4661,6 +4735,7 @@
           <a:lstStyle/>
           <a:p>
             <a:pPr algn="ctr"/>
+            <a:endParaRPr/>
           </a:p>
         </p:txBody>
       </p:sp>
@@ -4762,6 +4837,7 @@
           <a:lstStyle/>
           <a:p>
             <a:pPr algn="ctr"/>
+            <a:endParaRPr/>
           </a:p>
         </p:txBody>
       </p:sp>
@@ -4832,7 +4908,7 @@
 </file>
 
 <file path=ppt/slides/slide12.xml><?xml version="1.0" encoding="utf-8"?>
-<p:sld xmlns:a="http://schemas.openxmlformats.org/drawingml/2006/main" xmlns:p="http://schemas.openxmlformats.org/presentationml/2006/main" xmlns:r="http://schemas.openxmlformats.org/officeDocument/2006/relationships">
+<p:sld xmlns:a="http://schemas.openxmlformats.org/drawingml/2006/main" xmlns:r="http://schemas.openxmlformats.org/officeDocument/2006/relationships" xmlns:p="http://schemas.openxmlformats.org/presentationml/2006/main">
   <p:cSld>
     <p:spTree>
       <p:nvGrpSpPr>
@@ -4840,7 +4916,14 @@
         <p:cNvGrpSpPr/>
         <p:nvPr/>
       </p:nvGrpSpPr>
-      <p:grpSpPr/>
+      <p:grpSpPr>
+        <a:xfrm>
+          <a:off x="0" y="0"/>
+          <a:ext cx="0" cy="0"/>
+          <a:chOff x="0" y="0"/>
+          <a:chExt cx="0" cy="0"/>
+        </a:xfrm>
+      </p:grpSpPr>
       <p:sp>
         <p:nvSpPr>
           <p:cNvPr id="2" name="Rectangle 1"/>
@@ -4881,6 +4964,7 @@
           <a:lstStyle/>
           <a:p>
             <a:pPr algn="ctr"/>
+            <a:endParaRPr/>
           </a:p>
         </p:txBody>
       </p:sp>
@@ -4982,6 +5066,7 @@
           <a:lstStyle/>
           <a:p>
             <a:pPr algn="ctr"/>
+            <a:endParaRPr/>
           </a:p>
         </p:txBody>
       </p:sp>
@@ -5878,7 +5963,7 @@
 </file>
 
 <file path=ppt/slides/slide13.xml><?xml version="1.0" encoding="utf-8"?>
-<p:sld xmlns:a="http://schemas.openxmlformats.org/drawingml/2006/main" xmlns:p="http://schemas.openxmlformats.org/presentationml/2006/main" xmlns:r="http://schemas.openxmlformats.org/officeDocument/2006/relationships">
+<p:sld xmlns:a="http://schemas.openxmlformats.org/drawingml/2006/main" xmlns:r="http://schemas.openxmlformats.org/officeDocument/2006/relationships" xmlns:p="http://schemas.openxmlformats.org/presentationml/2006/main">
   <p:cSld>
     <p:spTree>
       <p:nvGrpSpPr>
@@ -5886,7 +5971,14 @@
         <p:cNvGrpSpPr/>
         <p:nvPr/>
       </p:nvGrpSpPr>
-      <p:grpSpPr/>
+      <p:grpSpPr>
+        <a:xfrm>
+          <a:off x="0" y="0"/>
+          <a:ext cx="0" cy="0"/>
+          <a:chOff x="0" y="0"/>
+          <a:chExt cx="0" cy="0"/>
+        </a:xfrm>
+      </p:grpSpPr>
       <p:sp>
         <p:nvSpPr>
           <p:cNvPr id="2" name="Rectangle 1"/>
@@ -5927,6 +6019,7 @@
           <a:lstStyle/>
           <a:p>
             <a:pPr algn="ctr"/>
+            <a:endParaRPr/>
           </a:p>
         </p:txBody>
       </p:sp>
@@ -6028,6 +6121,7 @@
           <a:lstStyle/>
           <a:p>
             <a:pPr algn="ctr"/>
+            <a:endParaRPr/>
           </a:p>
         </p:txBody>
       </p:sp>
@@ -6098,7 +6192,7 @@
 </file>
 
 <file path=ppt/slides/slide14.xml><?xml version="1.0" encoding="utf-8"?>
-<p:sld xmlns:a="http://schemas.openxmlformats.org/drawingml/2006/main" xmlns:p="http://schemas.openxmlformats.org/presentationml/2006/main" xmlns:r="http://schemas.openxmlformats.org/officeDocument/2006/relationships">
+<p:sld xmlns:a="http://schemas.openxmlformats.org/drawingml/2006/main" xmlns:r="http://schemas.openxmlformats.org/officeDocument/2006/relationships" xmlns:p="http://schemas.openxmlformats.org/presentationml/2006/main">
   <p:cSld>
     <p:spTree>
       <p:nvGrpSpPr>
@@ -6106,7 +6200,14 @@
         <p:cNvGrpSpPr/>
         <p:nvPr/>
       </p:nvGrpSpPr>
-      <p:grpSpPr/>
+      <p:grpSpPr>
+        <a:xfrm>
+          <a:off x="0" y="0"/>
+          <a:ext cx="0" cy="0"/>
+          <a:chOff x="0" y="0"/>
+          <a:chExt cx="0" cy="0"/>
+        </a:xfrm>
+      </p:grpSpPr>
       <p:sp>
         <p:nvSpPr>
           <p:cNvPr id="2" name="Rectangle 1"/>
@@ -6147,6 +6248,7 @@
           <a:lstStyle/>
           <a:p>
             <a:pPr algn="ctr"/>
+            <a:endParaRPr/>
           </a:p>
         </p:txBody>
       </p:sp>
@@ -6248,6 +6350,7 @@
           <a:lstStyle/>
           <a:p>
             <a:pPr algn="ctr"/>
+            <a:endParaRPr/>
           </a:p>
         </p:txBody>
       </p:sp>
@@ -6321,7 +6424,7 @@
           </a:fontRef>
         </p:style>
         <p:txBody>
-          <a:bodyPr rtlCol="0" anchor="ctr" wrap="square"/>
+          <a:bodyPr wrap="square" rtlCol="0" anchor="ctr"/>
           <a:lstStyle/>
           <a:p>
             <a:pPr algn="l"/>
@@ -6408,14 +6511,11 @@
                 <a:spcPts val="300"/>
               </a:spcBef>
             </a:pPr>
-            <a:r>
-              <a:rPr sz="1400">
-                <a:solidFill>
-                  <a:srgbClr val="212121"/>
-                </a:solidFill>
-              </a:rPr>
-              <a:t/>
-            </a:r>
+            <a:endParaRPr sz="1400">
+              <a:solidFill>
+                <a:srgbClr val="212121"/>
+              </a:solidFill>
+            </a:endParaRPr>
           </a:p>
           <a:p>
             <a:pPr algn="l">
@@ -6468,14 +6568,11 @@
                 <a:spcPts val="300"/>
               </a:spcBef>
             </a:pPr>
-            <a:r>
-              <a:rPr sz="1400">
-                <a:solidFill>
-                  <a:srgbClr val="212121"/>
-                </a:solidFill>
-              </a:rPr>
-              <a:t/>
-            </a:r>
+            <a:endParaRPr sz="1400">
+              <a:solidFill>
+                <a:srgbClr val="212121"/>
+              </a:solidFill>
+            </a:endParaRPr>
           </a:p>
           <a:p>
             <a:pPr algn="l">
@@ -6518,7 +6615,7 @@
 </file>
 
 <file path=ppt/slides/slide15.xml><?xml version="1.0" encoding="utf-8"?>
-<p:sld xmlns:a="http://schemas.openxmlformats.org/drawingml/2006/main" xmlns:p="http://schemas.openxmlformats.org/presentationml/2006/main" xmlns:r="http://schemas.openxmlformats.org/officeDocument/2006/relationships">
+<p:sld xmlns:a="http://schemas.openxmlformats.org/drawingml/2006/main" xmlns:r="http://schemas.openxmlformats.org/officeDocument/2006/relationships" xmlns:p="http://schemas.openxmlformats.org/presentationml/2006/main">
   <p:cSld>
     <p:spTree>
       <p:nvGrpSpPr>
@@ -6526,7 +6623,14 @@
         <p:cNvGrpSpPr/>
         <p:nvPr/>
       </p:nvGrpSpPr>
-      <p:grpSpPr/>
+      <p:grpSpPr>
+        <a:xfrm>
+          <a:off x="0" y="0"/>
+          <a:ext cx="0" cy="0"/>
+          <a:chOff x="0" y="0"/>
+          <a:chExt cx="0" cy="0"/>
+        </a:xfrm>
+      </p:grpSpPr>
       <p:sp>
         <p:nvSpPr>
           <p:cNvPr id="2" name="Rectangle 1"/>
@@ -6567,6 +6671,7 @@
           <a:lstStyle/>
           <a:p>
             <a:pPr algn="ctr"/>
+            <a:endParaRPr/>
           </a:p>
         </p:txBody>
       </p:sp>
@@ -6668,6 +6773,7 @@
           <a:lstStyle/>
           <a:p>
             <a:pPr algn="ctr"/>
+            <a:endParaRPr/>
           </a:p>
         </p:txBody>
       </p:sp>
@@ -6777,14 +6883,11 @@
                 <a:spcPts val="300"/>
               </a:spcBef>
             </a:pPr>
-            <a:r>
-              <a:rPr sz="1400">
-                <a:solidFill>
-                  <a:srgbClr val="212121"/>
-                </a:solidFill>
-              </a:rPr>
-              <a:t/>
-            </a:r>
+            <a:endParaRPr sz="1400">
+              <a:solidFill>
+                <a:srgbClr val="212121"/>
+              </a:solidFill>
+            </a:endParaRPr>
           </a:p>
           <a:p>
             <a:pPr algn="l">
@@ -6837,14 +6940,11 @@
                 <a:spcPts val="300"/>
               </a:spcBef>
             </a:pPr>
-            <a:r>
-              <a:rPr sz="1400">
-                <a:solidFill>
-                  <a:srgbClr val="212121"/>
-                </a:solidFill>
-              </a:rPr>
-              <a:t/>
-            </a:r>
+            <a:endParaRPr sz="1400">
+              <a:solidFill>
+                <a:srgbClr val="212121"/>
+              </a:solidFill>
+            </a:endParaRPr>
           </a:p>
           <a:p>
             <a:pPr algn="l">
@@ -6897,14 +6997,11 @@
                 <a:spcPts val="300"/>
               </a:spcBef>
             </a:pPr>
-            <a:r>
-              <a:rPr sz="1400">
-                <a:solidFill>
-                  <a:srgbClr val="212121"/>
-                </a:solidFill>
-              </a:rPr>
-              <a:t/>
-            </a:r>
+            <a:endParaRPr sz="1400">
+              <a:solidFill>
+                <a:srgbClr val="212121"/>
+              </a:solidFill>
+            </a:endParaRPr>
           </a:p>
           <a:p>
             <a:pPr algn="l">
@@ -6947,7 +7044,7 @@
 </file>
 
 <file path=ppt/slides/slide16.xml><?xml version="1.0" encoding="utf-8"?>
-<p:sld xmlns:a="http://schemas.openxmlformats.org/drawingml/2006/main" xmlns:p="http://schemas.openxmlformats.org/presentationml/2006/main" xmlns:r="http://schemas.openxmlformats.org/officeDocument/2006/relationships">
+<p:sld xmlns:a="http://schemas.openxmlformats.org/drawingml/2006/main" xmlns:r="http://schemas.openxmlformats.org/officeDocument/2006/relationships" xmlns:p="http://schemas.openxmlformats.org/presentationml/2006/main">
   <p:cSld>
     <p:spTree>
       <p:nvGrpSpPr>
@@ -6955,7 +7052,14 @@
         <p:cNvGrpSpPr/>
         <p:nvPr/>
       </p:nvGrpSpPr>
-      <p:grpSpPr/>
+      <p:grpSpPr>
+        <a:xfrm>
+          <a:off x="0" y="0"/>
+          <a:ext cx="0" cy="0"/>
+          <a:chOff x="0" y="0"/>
+          <a:chExt cx="0" cy="0"/>
+        </a:xfrm>
+      </p:grpSpPr>
       <p:sp>
         <p:nvSpPr>
           <p:cNvPr id="2" name="Rectangle 1"/>
@@ -6996,6 +7100,7 @@
           <a:lstStyle/>
           <a:p>
             <a:pPr algn="ctr"/>
+            <a:endParaRPr/>
           </a:p>
         </p:txBody>
       </p:sp>
@@ -7097,6 +7202,7 @@
           <a:lstStyle/>
           <a:p>
             <a:pPr algn="ctr"/>
+            <a:endParaRPr/>
           </a:p>
         </p:txBody>
       </p:sp>
@@ -7236,14 +7342,11 @@
                 <a:spcPts val="700"/>
               </a:spcBef>
             </a:pPr>
-            <a:r>
-              <a:rPr sz="1600">
-                <a:solidFill>
-                  <a:srgbClr val="212121"/>
-                </a:solidFill>
-              </a:rPr>
-              <a:t/>
-            </a:r>
+            <a:endParaRPr sz="1600">
+              <a:solidFill>
+                <a:srgbClr val="212121"/>
+              </a:solidFill>
+            </a:endParaRPr>
           </a:p>
           <a:p>
             <a:pPr algn="l">
@@ -7286,7 +7389,7 @@
 </file>
 
 <file path=ppt/slides/slide17.xml><?xml version="1.0" encoding="utf-8"?>
-<p:sld xmlns:a="http://schemas.openxmlformats.org/drawingml/2006/main" xmlns:p="http://schemas.openxmlformats.org/presentationml/2006/main" xmlns:r="http://schemas.openxmlformats.org/officeDocument/2006/relationships">
+<p:sld xmlns:a="http://schemas.openxmlformats.org/drawingml/2006/main" xmlns:r="http://schemas.openxmlformats.org/officeDocument/2006/relationships" xmlns:p="http://schemas.openxmlformats.org/presentationml/2006/main">
   <p:cSld>
     <p:spTree>
       <p:nvGrpSpPr>
@@ -7294,7 +7397,14 @@
         <p:cNvGrpSpPr/>
         <p:nvPr/>
       </p:nvGrpSpPr>
-      <p:grpSpPr/>
+      <p:grpSpPr>
+        <a:xfrm>
+          <a:off x="0" y="0"/>
+          <a:ext cx="0" cy="0"/>
+          <a:chOff x="0" y="0"/>
+          <a:chExt cx="0" cy="0"/>
+        </a:xfrm>
+      </p:grpSpPr>
       <p:sp>
         <p:nvSpPr>
           <p:cNvPr id="2" name="Rectangle 1"/>
@@ -7335,6 +7445,7 @@
           <a:lstStyle/>
           <a:p>
             <a:pPr algn="ctr"/>
+            <a:endParaRPr/>
           </a:p>
         </p:txBody>
       </p:sp>
@@ -7436,6 +7547,7 @@
           <a:lstStyle/>
           <a:p>
             <a:pPr algn="ctr"/>
+            <a:endParaRPr/>
           </a:p>
         </p:txBody>
       </p:sp>
@@ -7738,8 +7850,8 @@
         </p:blipFill>
         <p:spPr>
           <a:xfrm>
-            <a:off x="5943600" y="1143000"/>
-            <a:ext cx="5852160" cy="5349240"/>
+            <a:off x="4892040" y="1143000"/>
+            <a:ext cx="6903720" cy="5349240"/>
           </a:xfrm>
           <a:prstGeom prst="rect">
             <a:avLst/>
@@ -7755,7 +7867,7 @@
 </file>
 
 <file path=ppt/slides/slide18.xml><?xml version="1.0" encoding="utf-8"?>
-<p:sld xmlns:a="http://schemas.openxmlformats.org/drawingml/2006/main" xmlns:p="http://schemas.openxmlformats.org/presentationml/2006/main" xmlns:r="http://schemas.openxmlformats.org/officeDocument/2006/relationships">
+<p:sld xmlns:a="http://schemas.openxmlformats.org/drawingml/2006/main" xmlns:r="http://schemas.openxmlformats.org/officeDocument/2006/relationships" xmlns:p="http://schemas.openxmlformats.org/presentationml/2006/main">
   <p:cSld>
     <p:spTree>
       <p:nvGrpSpPr>
@@ -7763,7 +7875,14 @@
         <p:cNvGrpSpPr/>
         <p:nvPr/>
       </p:nvGrpSpPr>
-      <p:grpSpPr/>
+      <p:grpSpPr>
+        <a:xfrm>
+          <a:off x="0" y="0"/>
+          <a:ext cx="0" cy="0"/>
+          <a:chOff x="0" y="0"/>
+          <a:chExt cx="0" cy="0"/>
+        </a:xfrm>
+      </p:grpSpPr>
       <p:sp>
         <p:nvSpPr>
           <p:cNvPr id="2" name="Rectangle 1"/>
@@ -7804,6 +7923,7 @@
           <a:lstStyle/>
           <a:p>
             <a:pPr algn="ctr"/>
+            <a:endParaRPr/>
           </a:p>
         </p:txBody>
       </p:sp>
@@ -7847,6 +7967,7 @@
           <a:lstStyle/>
           <a:p>
             <a:pPr algn="ctr"/>
+            <a:endParaRPr/>
           </a:p>
         </p:txBody>
       </p:sp>
@@ -7914,6 +8035,7 @@
           <a:lstStyle/>
           <a:p>
             <a:pPr algn="ctr"/>
+            <a:endParaRPr/>
           </a:p>
         </p:txBody>
       </p:sp>
@@ -8093,6 +8215,7 @@
           <a:lstStyle/>
           <a:p>
             <a:pPr algn="ctr"/>
+            <a:endParaRPr/>
           </a:p>
         </p:txBody>
       </p:sp>
@@ -8139,7 +8262,7 @@
 </file>
 
 <file path=ppt/slides/slide19.xml><?xml version="1.0" encoding="utf-8"?>
-<p:sld xmlns:a="http://schemas.openxmlformats.org/drawingml/2006/main" xmlns:p="http://schemas.openxmlformats.org/presentationml/2006/main" xmlns:r="http://schemas.openxmlformats.org/officeDocument/2006/relationships">
+<p:sld xmlns:a="http://schemas.openxmlformats.org/drawingml/2006/main" xmlns:r="http://schemas.openxmlformats.org/officeDocument/2006/relationships" xmlns:p="http://schemas.openxmlformats.org/presentationml/2006/main">
   <p:cSld>
     <p:spTree>
       <p:nvGrpSpPr>
@@ -8147,7 +8270,14 @@
         <p:cNvGrpSpPr/>
         <p:nvPr/>
       </p:nvGrpSpPr>
-      <p:grpSpPr/>
+      <p:grpSpPr>
+        <a:xfrm>
+          <a:off x="0" y="0"/>
+          <a:ext cx="0" cy="0"/>
+          <a:chOff x="0" y="0"/>
+          <a:chExt cx="0" cy="0"/>
+        </a:xfrm>
+      </p:grpSpPr>
       <p:sp>
         <p:nvSpPr>
           <p:cNvPr id="2" name="Rectangle 1"/>
@@ -8188,6 +8318,7 @@
           <a:lstStyle/>
           <a:p>
             <a:pPr algn="ctr"/>
+            <a:endParaRPr/>
           </a:p>
         </p:txBody>
       </p:sp>
@@ -8289,6 +8420,7 @@
           <a:lstStyle/>
           <a:p>
             <a:pPr algn="ctr"/>
+            <a:endParaRPr/>
           </a:p>
         </p:txBody>
       </p:sp>
@@ -8359,7 +8491,7 @@
 </file>
 
 <file path=ppt/slides/slide2.xml><?xml version="1.0" encoding="utf-8"?>
-<p:sld xmlns:a="http://schemas.openxmlformats.org/drawingml/2006/main" xmlns:p="http://schemas.openxmlformats.org/presentationml/2006/main" xmlns:r="http://schemas.openxmlformats.org/officeDocument/2006/relationships">
+<p:sld xmlns:a="http://schemas.openxmlformats.org/drawingml/2006/main" xmlns:r="http://schemas.openxmlformats.org/officeDocument/2006/relationships" xmlns:p="http://schemas.openxmlformats.org/presentationml/2006/main">
   <p:cSld>
     <p:spTree>
       <p:nvGrpSpPr>
@@ -8367,7 +8499,14 @@
         <p:cNvGrpSpPr/>
         <p:nvPr/>
       </p:nvGrpSpPr>
-      <p:grpSpPr/>
+      <p:grpSpPr>
+        <a:xfrm>
+          <a:off x="0" y="0"/>
+          <a:ext cx="0" cy="0"/>
+          <a:chOff x="0" y="0"/>
+          <a:chExt cx="0" cy="0"/>
+        </a:xfrm>
+      </p:grpSpPr>
       <p:sp>
         <p:nvSpPr>
           <p:cNvPr id="2" name="Rectangle 1"/>
@@ -8408,6 +8547,7 @@
           <a:lstStyle/>
           <a:p>
             <a:pPr algn="ctr"/>
+            <a:endParaRPr/>
           </a:p>
         </p:txBody>
       </p:sp>
@@ -8509,6 +8649,7 @@
           <a:lstStyle/>
           <a:p>
             <a:pPr algn="ctr"/>
+            <a:endParaRPr/>
           </a:p>
         </p:txBody>
       </p:sp>
@@ -8648,14 +8789,11 @@
                 <a:spcPts val="300"/>
               </a:spcBef>
             </a:pPr>
-            <a:r>
-              <a:rPr sz="1600">
-                <a:solidFill>
-                  <a:srgbClr val="212121"/>
-                </a:solidFill>
-              </a:rPr>
-              <a:t/>
-            </a:r>
+            <a:endParaRPr sz="1600">
+              <a:solidFill>
+                <a:srgbClr val="212121"/>
+              </a:solidFill>
+            </a:endParaRPr>
           </a:p>
           <a:p>
             <a:pPr algn="l">
@@ -8698,7 +8836,7 @@
 </file>
 
 <file path=ppt/slides/slide20.xml><?xml version="1.0" encoding="utf-8"?>
-<p:sld xmlns:a="http://schemas.openxmlformats.org/drawingml/2006/main" xmlns:p="http://schemas.openxmlformats.org/presentationml/2006/main" xmlns:r="http://schemas.openxmlformats.org/officeDocument/2006/relationships">
+<p:sld xmlns:a="http://schemas.openxmlformats.org/drawingml/2006/main" xmlns:r="http://schemas.openxmlformats.org/officeDocument/2006/relationships" xmlns:p="http://schemas.openxmlformats.org/presentationml/2006/main">
   <p:cSld>
     <p:spTree>
       <p:nvGrpSpPr>
@@ -8706,7 +8844,14 @@
         <p:cNvGrpSpPr/>
         <p:nvPr/>
       </p:nvGrpSpPr>
-      <p:grpSpPr/>
+      <p:grpSpPr>
+        <a:xfrm>
+          <a:off x="0" y="0"/>
+          <a:ext cx="0" cy="0"/>
+          <a:chOff x="0" y="0"/>
+          <a:chExt cx="0" cy="0"/>
+        </a:xfrm>
+      </p:grpSpPr>
       <p:sp>
         <p:nvSpPr>
           <p:cNvPr id="2" name="Rectangle 1"/>
@@ -8747,6 +8892,7 @@
           <a:lstStyle/>
           <a:p>
             <a:pPr algn="ctr"/>
+            <a:endParaRPr/>
           </a:p>
         </p:txBody>
       </p:sp>
@@ -8848,6 +8994,7 @@
           <a:lstStyle/>
           <a:p>
             <a:pPr algn="ctr"/>
+            <a:endParaRPr/>
           </a:p>
         </p:txBody>
       </p:sp>
@@ -8918,7 +9065,7 @@
 </file>
 
 <file path=ppt/slides/slide21.xml><?xml version="1.0" encoding="utf-8"?>
-<p:sld xmlns:a="http://schemas.openxmlformats.org/drawingml/2006/main" xmlns:p="http://schemas.openxmlformats.org/presentationml/2006/main" xmlns:r="http://schemas.openxmlformats.org/officeDocument/2006/relationships">
+<p:sld xmlns:a="http://schemas.openxmlformats.org/drawingml/2006/main" xmlns:r="http://schemas.openxmlformats.org/officeDocument/2006/relationships" xmlns:p="http://schemas.openxmlformats.org/presentationml/2006/main">
   <p:cSld>
     <p:spTree>
       <p:nvGrpSpPr>
@@ -8926,7 +9073,14 @@
         <p:cNvGrpSpPr/>
         <p:nvPr/>
       </p:nvGrpSpPr>
-      <p:grpSpPr/>
+      <p:grpSpPr>
+        <a:xfrm>
+          <a:off x="0" y="0"/>
+          <a:ext cx="0" cy="0"/>
+          <a:chOff x="0" y="0"/>
+          <a:chExt cx="0" cy="0"/>
+        </a:xfrm>
+      </p:grpSpPr>
       <p:sp>
         <p:nvSpPr>
           <p:cNvPr id="2" name="Rectangle 1"/>
@@ -8967,6 +9121,7 @@
           <a:lstStyle/>
           <a:p>
             <a:pPr algn="ctr"/>
+            <a:endParaRPr/>
           </a:p>
         </p:txBody>
       </p:sp>
@@ -9068,6 +9223,7 @@
           <a:lstStyle/>
           <a:p>
             <a:pPr algn="ctr"/>
+            <a:endParaRPr/>
           </a:p>
         </p:txBody>
       </p:sp>
@@ -9294,7 +9450,7 @@
           </a:fontRef>
         </p:style>
         <p:txBody>
-          <a:bodyPr rtlCol="0" anchor="ctr" wrap="square"/>
+          <a:bodyPr wrap="square" rtlCol="0" anchor="ctr"/>
           <a:lstStyle/>
           <a:p>
             <a:pPr algn="l"/>
@@ -9345,7 +9501,7 @@
           </a:fontRef>
         </p:style>
         <p:txBody>
-          <a:bodyPr rtlCol="0" anchor="ctr" wrap="square"/>
+          <a:bodyPr wrap="square" rtlCol="0" anchor="ctr"/>
           <a:lstStyle/>
           <a:p>
             <a:pPr algn="l"/>
@@ -9396,7 +9552,7 @@
           </a:fontRef>
         </p:style>
         <p:txBody>
-          <a:bodyPr rtlCol="0" anchor="ctr" wrap="square"/>
+          <a:bodyPr wrap="square" rtlCol="0" anchor="ctr"/>
           <a:lstStyle/>
           <a:p>
             <a:pPr algn="l"/>
@@ -9447,7 +9603,7 @@
           </a:fontRef>
         </p:style>
         <p:txBody>
-          <a:bodyPr rtlCol="0" anchor="ctr" wrap="square"/>
+          <a:bodyPr wrap="square" rtlCol="0" anchor="ctr"/>
           <a:lstStyle/>
           <a:p>
             <a:pPr algn="l"/>
@@ -9498,7 +9654,7 @@
           </a:fontRef>
         </p:style>
         <p:txBody>
-          <a:bodyPr rtlCol="0" anchor="ctr" wrap="square"/>
+          <a:bodyPr wrap="square" rtlCol="0" anchor="ctr"/>
           <a:lstStyle/>
           <a:p>
             <a:pPr algn="l"/>
@@ -9549,7 +9705,7 @@
           </a:fontRef>
         </p:style>
         <p:txBody>
-          <a:bodyPr rtlCol="0" anchor="ctr" wrap="square"/>
+          <a:bodyPr wrap="square" rtlCol="0" anchor="ctr"/>
           <a:lstStyle/>
           <a:p>
             <a:pPr algn="l"/>
@@ -9600,7 +9756,7 @@
           </a:fontRef>
         </p:style>
         <p:txBody>
-          <a:bodyPr rtlCol="0" anchor="ctr" wrap="square"/>
+          <a:bodyPr wrap="square" rtlCol="0" anchor="ctr"/>
           <a:lstStyle/>
           <a:p>
             <a:pPr algn="l"/>
@@ -9651,7 +9807,7 @@
           </a:fontRef>
         </p:style>
         <p:txBody>
-          <a:bodyPr rtlCol="0" anchor="ctr" wrap="square"/>
+          <a:bodyPr wrap="square" rtlCol="0" anchor="ctr"/>
           <a:lstStyle/>
           <a:p>
             <a:pPr algn="l"/>
@@ -9702,7 +9858,7 @@
           </a:fontRef>
         </p:style>
         <p:txBody>
-          <a:bodyPr rtlCol="0" anchor="ctr" wrap="square"/>
+          <a:bodyPr wrap="square" rtlCol="0" anchor="ctr"/>
           <a:lstStyle/>
           <a:p>
             <a:pPr algn="l"/>
@@ -9753,7 +9909,7 @@
           </a:fontRef>
         </p:style>
         <p:txBody>
-          <a:bodyPr rtlCol="0" anchor="ctr" wrap="square"/>
+          <a:bodyPr wrap="square" rtlCol="0" anchor="ctr"/>
           <a:lstStyle/>
           <a:p>
             <a:pPr algn="l"/>
@@ -9804,7 +9960,7 @@
           </a:fontRef>
         </p:style>
         <p:txBody>
-          <a:bodyPr rtlCol="0" anchor="ctr" wrap="square"/>
+          <a:bodyPr wrap="square" rtlCol="0" anchor="ctr"/>
           <a:lstStyle/>
           <a:p>
             <a:pPr algn="l"/>
@@ -9855,7 +10011,7 @@
           </a:fontRef>
         </p:style>
         <p:txBody>
-          <a:bodyPr rtlCol="0" anchor="ctr" wrap="square"/>
+          <a:bodyPr wrap="square" rtlCol="0" anchor="ctr"/>
           <a:lstStyle/>
           <a:p>
             <a:pPr algn="l"/>
@@ -9906,7 +10062,7 @@
           </a:fontRef>
         </p:style>
         <p:txBody>
-          <a:bodyPr rtlCol="0" anchor="ctr" wrap="square"/>
+          <a:bodyPr wrap="square" rtlCol="0" anchor="ctr"/>
           <a:lstStyle/>
           <a:p>
             <a:pPr algn="l"/>
@@ -9957,7 +10113,7 @@
           </a:fontRef>
         </p:style>
         <p:txBody>
-          <a:bodyPr rtlCol="0" anchor="ctr" wrap="square"/>
+          <a:bodyPr wrap="square" rtlCol="0" anchor="ctr"/>
           <a:lstStyle/>
           <a:p>
             <a:pPr algn="l"/>
@@ -10008,7 +10164,7 @@
           </a:fontRef>
         </p:style>
         <p:txBody>
-          <a:bodyPr rtlCol="0" anchor="ctr" wrap="square"/>
+          <a:bodyPr wrap="square" rtlCol="0" anchor="ctr"/>
           <a:lstStyle/>
           <a:p>
             <a:pPr algn="l"/>
@@ -10059,7 +10215,7 @@
           </a:fontRef>
         </p:style>
         <p:txBody>
-          <a:bodyPr rtlCol="0" anchor="ctr" wrap="square"/>
+          <a:bodyPr wrap="square" rtlCol="0" anchor="ctr"/>
           <a:lstStyle/>
           <a:p>
             <a:pPr algn="l"/>
@@ -10110,7 +10266,7 @@
           </a:fontRef>
         </p:style>
         <p:txBody>
-          <a:bodyPr rtlCol="0" anchor="ctr" wrap="square"/>
+          <a:bodyPr wrap="square" rtlCol="0" anchor="ctr"/>
           <a:lstStyle/>
           <a:p>
             <a:pPr algn="l"/>
@@ -10161,7 +10317,7 @@
           </a:fontRef>
         </p:style>
         <p:txBody>
-          <a:bodyPr rtlCol="0" anchor="ctr" wrap="square"/>
+          <a:bodyPr wrap="square" rtlCol="0" anchor="ctr"/>
           <a:lstStyle/>
           <a:p>
             <a:pPr algn="l"/>
@@ -10212,7 +10368,7 @@
           </a:fontRef>
         </p:style>
         <p:txBody>
-          <a:bodyPr rtlCol="0" anchor="ctr" wrap="square"/>
+          <a:bodyPr wrap="square" rtlCol="0" anchor="ctr"/>
           <a:lstStyle/>
           <a:p>
             <a:pPr algn="l"/>
@@ -10263,7 +10419,7 @@
           </a:fontRef>
         </p:style>
         <p:txBody>
-          <a:bodyPr rtlCol="0" anchor="ctr" wrap="square"/>
+          <a:bodyPr wrap="square" rtlCol="0" anchor="ctr"/>
           <a:lstStyle/>
           <a:p>
             <a:pPr algn="l"/>
@@ -10314,7 +10470,7 @@
           </a:fontRef>
         </p:style>
         <p:txBody>
-          <a:bodyPr rtlCol="0" anchor="ctr" wrap="square"/>
+          <a:bodyPr wrap="square" rtlCol="0" anchor="ctr"/>
           <a:lstStyle/>
           <a:p>
             <a:pPr algn="l"/>
@@ -10365,7 +10521,7 @@
           </a:fontRef>
         </p:style>
         <p:txBody>
-          <a:bodyPr rtlCol="0" anchor="ctr" wrap="square"/>
+          <a:bodyPr wrap="square" rtlCol="0" anchor="ctr"/>
           <a:lstStyle/>
           <a:p>
             <a:pPr algn="l"/>
@@ -10416,7 +10572,7 @@
           </a:fontRef>
         </p:style>
         <p:txBody>
-          <a:bodyPr rtlCol="0" anchor="ctr" wrap="square"/>
+          <a:bodyPr wrap="square" rtlCol="0" anchor="ctr"/>
           <a:lstStyle/>
           <a:p>
             <a:pPr algn="l"/>
@@ -10467,7 +10623,7 @@
           </a:fontRef>
         </p:style>
         <p:txBody>
-          <a:bodyPr rtlCol="0" anchor="ctr" wrap="square"/>
+          <a:bodyPr wrap="square" rtlCol="0" anchor="ctr"/>
           <a:lstStyle/>
           <a:p>
             <a:pPr algn="l"/>
@@ -10518,7 +10674,7 @@
           </a:fontRef>
         </p:style>
         <p:txBody>
-          <a:bodyPr rtlCol="0" anchor="ctr" wrap="square"/>
+          <a:bodyPr wrap="square" rtlCol="0" anchor="ctr"/>
           <a:lstStyle/>
           <a:p>
             <a:pPr algn="l"/>
@@ -10569,7 +10725,7 @@
           </a:fontRef>
         </p:style>
         <p:txBody>
-          <a:bodyPr rtlCol="0" anchor="ctr" wrap="square"/>
+          <a:bodyPr wrap="square" rtlCol="0" anchor="ctr"/>
           <a:lstStyle/>
           <a:p>
             <a:pPr algn="l"/>
@@ -10620,7 +10776,7 @@
           </a:fontRef>
         </p:style>
         <p:txBody>
-          <a:bodyPr rtlCol="0" anchor="ctr" wrap="square"/>
+          <a:bodyPr wrap="square" rtlCol="0" anchor="ctr"/>
           <a:lstStyle/>
           <a:p>
             <a:pPr algn="l"/>
@@ -10671,7 +10827,7 @@
           </a:fontRef>
         </p:style>
         <p:txBody>
-          <a:bodyPr rtlCol="0" anchor="ctr" wrap="square"/>
+          <a:bodyPr wrap="square" rtlCol="0" anchor="ctr"/>
           <a:lstStyle/>
           <a:p>
             <a:pPr algn="l"/>
@@ -10722,7 +10878,7 @@
           </a:fontRef>
         </p:style>
         <p:txBody>
-          <a:bodyPr rtlCol="0" anchor="ctr" wrap="square"/>
+          <a:bodyPr wrap="square" rtlCol="0" anchor="ctr"/>
           <a:lstStyle/>
           <a:p>
             <a:pPr algn="l"/>
@@ -10773,7 +10929,7 @@
           </a:fontRef>
         </p:style>
         <p:txBody>
-          <a:bodyPr rtlCol="0" anchor="ctr" wrap="square"/>
+          <a:bodyPr wrap="square" rtlCol="0" anchor="ctr"/>
           <a:lstStyle/>
           <a:p>
             <a:pPr algn="l"/>
@@ -10824,7 +10980,7 @@
           </a:fontRef>
         </p:style>
         <p:txBody>
-          <a:bodyPr rtlCol="0" anchor="ctr" wrap="square"/>
+          <a:bodyPr wrap="square" rtlCol="0" anchor="ctr"/>
           <a:lstStyle/>
           <a:p>
             <a:pPr algn="l"/>
@@ -10875,7 +11031,7 @@
           </a:fontRef>
         </p:style>
         <p:txBody>
-          <a:bodyPr rtlCol="0" anchor="ctr" wrap="square"/>
+          <a:bodyPr wrap="square" rtlCol="0" anchor="ctr"/>
           <a:lstStyle/>
           <a:p>
             <a:pPr algn="l"/>
@@ -10926,7 +11082,7 @@
           </a:fontRef>
         </p:style>
         <p:txBody>
-          <a:bodyPr rtlCol="0" anchor="ctr" wrap="square"/>
+          <a:bodyPr wrap="square" rtlCol="0" anchor="ctr"/>
           <a:lstStyle/>
           <a:p>
             <a:pPr algn="l"/>
@@ -10950,7 +11106,7 @@
 </file>
 
 <file path=ppt/slides/slide3.xml><?xml version="1.0" encoding="utf-8"?>
-<p:sld xmlns:a="http://schemas.openxmlformats.org/drawingml/2006/main" xmlns:p="http://schemas.openxmlformats.org/presentationml/2006/main" xmlns:r="http://schemas.openxmlformats.org/officeDocument/2006/relationships">
+<p:sld xmlns:a="http://schemas.openxmlformats.org/drawingml/2006/main" xmlns:r="http://schemas.openxmlformats.org/officeDocument/2006/relationships" xmlns:p="http://schemas.openxmlformats.org/presentationml/2006/main">
   <p:cSld>
     <p:spTree>
       <p:nvGrpSpPr>
@@ -10958,7 +11114,14 @@
         <p:cNvGrpSpPr/>
         <p:nvPr/>
       </p:nvGrpSpPr>
-      <p:grpSpPr/>
+      <p:grpSpPr>
+        <a:xfrm>
+          <a:off x="0" y="0"/>
+          <a:ext cx="0" cy="0"/>
+          <a:chOff x="0" y="0"/>
+          <a:chExt cx="0" cy="0"/>
+        </a:xfrm>
+      </p:grpSpPr>
       <p:sp>
         <p:nvSpPr>
           <p:cNvPr id="2" name="Rectangle 1"/>
@@ -10999,6 +11162,7 @@
           <a:lstStyle/>
           <a:p>
             <a:pPr algn="ctr"/>
+            <a:endParaRPr/>
           </a:p>
         </p:txBody>
       </p:sp>
@@ -11100,6 +11264,7 @@
           <a:lstStyle/>
           <a:p>
             <a:pPr algn="ctr"/>
+            <a:endParaRPr/>
           </a:p>
         </p:txBody>
       </p:sp>
@@ -11177,6 +11342,7 @@
           <a:lstStyle/>
           <a:p>
             <a:pPr algn="ctr"/>
+            <a:endParaRPr/>
           </a:p>
         </p:txBody>
       </p:sp>
@@ -11386,6 +11552,7 @@
           <a:lstStyle/>
           <a:p>
             <a:pPr algn="ctr"/>
+            <a:endParaRPr/>
           </a:p>
         </p:txBody>
       </p:sp>
@@ -11530,7 +11697,7 @@
 </file>
 
 <file path=ppt/slides/slide4.xml><?xml version="1.0" encoding="utf-8"?>
-<p:sld xmlns:a="http://schemas.openxmlformats.org/drawingml/2006/main" xmlns:p="http://schemas.openxmlformats.org/presentationml/2006/main" xmlns:r="http://schemas.openxmlformats.org/officeDocument/2006/relationships">
+<p:sld xmlns:a="http://schemas.openxmlformats.org/drawingml/2006/main" xmlns:r="http://schemas.openxmlformats.org/officeDocument/2006/relationships" xmlns:p="http://schemas.openxmlformats.org/presentationml/2006/main">
   <p:cSld>
     <p:spTree>
       <p:nvGrpSpPr>
@@ -11538,7 +11705,14 @@
         <p:cNvGrpSpPr/>
         <p:nvPr/>
       </p:nvGrpSpPr>
-      <p:grpSpPr/>
+      <p:grpSpPr>
+        <a:xfrm>
+          <a:off x="0" y="0"/>
+          <a:ext cx="0" cy="0"/>
+          <a:chOff x="0" y="0"/>
+          <a:chExt cx="0" cy="0"/>
+        </a:xfrm>
+      </p:grpSpPr>
       <p:sp>
         <p:nvSpPr>
           <p:cNvPr id="2" name="Rectangle 1"/>
@@ -11579,6 +11753,7 @@
           <a:lstStyle/>
           <a:p>
             <a:pPr algn="ctr"/>
+            <a:endParaRPr/>
           </a:p>
         </p:txBody>
       </p:sp>
@@ -11680,6 +11855,7 @@
           <a:lstStyle/>
           <a:p>
             <a:pPr algn="ctr"/>
+            <a:endParaRPr/>
           </a:p>
         </p:txBody>
       </p:sp>
@@ -11869,7 +12045,7 @@
 </file>
 
 <file path=ppt/slides/slide5.xml><?xml version="1.0" encoding="utf-8"?>
-<p:sld xmlns:a="http://schemas.openxmlformats.org/drawingml/2006/main" xmlns:p="http://schemas.openxmlformats.org/presentationml/2006/main" xmlns:r="http://schemas.openxmlformats.org/officeDocument/2006/relationships">
+<p:sld xmlns:a="http://schemas.openxmlformats.org/drawingml/2006/main" xmlns:r="http://schemas.openxmlformats.org/officeDocument/2006/relationships" xmlns:p="http://schemas.openxmlformats.org/presentationml/2006/main">
   <p:cSld>
     <p:spTree>
       <p:nvGrpSpPr>
@@ -11877,7 +12053,14 @@
         <p:cNvGrpSpPr/>
         <p:nvPr/>
       </p:nvGrpSpPr>
-      <p:grpSpPr/>
+      <p:grpSpPr>
+        <a:xfrm>
+          <a:off x="0" y="0"/>
+          <a:ext cx="0" cy="0"/>
+          <a:chOff x="0" y="0"/>
+          <a:chExt cx="0" cy="0"/>
+        </a:xfrm>
+      </p:grpSpPr>
       <p:sp>
         <p:nvSpPr>
           <p:cNvPr id="2" name="Rectangle 1"/>
@@ -11918,6 +12101,7 @@
           <a:lstStyle/>
           <a:p>
             <a:pPr algn="ctr"/>
+            <a:endParaRPr/>
           </a:p>
         </p:txBody>
       </p:sp>
@@ -12019,6 +12203,7 @@
           <a:lstStyle/>
           <a:p>
             <a:pPr algn="ctr"/>
+            <a:endParaRPr/>
           </a:p>
         </p:txBody>
       </p:sp>
@@ -12092,7 +12277,7 @@
           </a:fontRef>
         </p:style>
         <p:txBody>
-          <a:bodyPr rtlCol="0" anchor="ctr" wrap="square"/>
+          <a:bodyPr wrap="square" rtlCol="0" anchor="ctr"/>
           <a:lstStyle/>
           <a:p>
             <a:pPr algn="ctr"/>
@@ -12177,7 +12362,7 @@
           </a:fontRef>
         </p:style>
         <p:txBody>
-          <a:bodyPr rtlCol="0" anchor="ctr" wrap="square"/>
+          <a:bodyPr wrap="square" rtlCol="0" anchor="ctr"/>
           <a:lstStyle/>
           <a:p>
             <a:pPr algn="ctr"/>
@@ -12263,7 +12448,7 @@
           </a:fontRef>
         </p:style>
         <p:txBody>
-          <a:bodyPr rtlCol="0" anchor="ctr" wrap="square"/>
+          <a:bodyPr wrap="square" rtlCol="0" anchor="ctr"/>
           <a:lstStyle/>
           <a:p>
             <a:pPr algn="ctr"/>
@@ -12349,7 +12534,7 @@
           </a:fontRef>
         </p:style>
         <p:txBody>
-          <a:bodyPr rtlCol="0" anchor="ctr" wrap="square"/>
+          <a:bodyPr wrap="square" rtlCol="0" anchor="ctr"/>
           <a:lstStyle/>
           <a:p>
             <a:pPr algn="ctr"/>
@@ -12435,7 +12620,7 @@
           </a:fontRef>
         </p:style>
         <p:txBody>
-          <a:bodyPr rtlCol="0" anchor="ctr" wrap="square"/>
+          <a:bodyPr wrap="square" rtlCol="0" anchor="ctr"/>
           <a:lstStyle/>
           <a:p>
             <a:pPr algn="ctr"/>
@@ -12490,6 +12675,7 @@
           <a:lstStyle/>
           <a:p>
             <a:pPr algn="ctr"/>
+            <a:endParaRPr/>
           </a:p>
         </p:txBody>
       </p:sp>
@@ -12580,14 +12766,11 @@
                 <a:spcPts val="300"/>
               </a:spcBef>
             </a:pPr>
-            <a:r>
-              <a:rPr sz="1100">
-                <a:solidFill>
-                  <a:srgbClr val="212121"/>
-                </a:solidFill>
-              </a:rPr>
-              <a:t/>
-            </a:r>
+            <a:endParaRPr sz="1100">
+              <a:solidFill>
+                <a:srgbClr val="212121"/>
+              </a:solidFill>
+            </a:endParaRPr>
           </a:p>
           <a:p>
             <a:pPr algn="l">
@@ -12640,14 +12823,11 @@
                 <a:spcPts val="300"/>
               </a:spcBef>
             </a:pPr>
-            <a:r>
-              <a:rPr sz="1100">
-                <a:solidFill>
-                  <a:srgbClr val="212121"/>
-                </a:solidFill>
-              </a:rPr>
-              <a:t/>
-            </a:r>
+            <a:endParaRPr sz="1100">
+              <a:solidFill>
+                <a:srgbClr val="212121"/>
+              </a:solidFill>
+            </a:endParaRPr>
           </a:p>
           <a:p>
             <a:pPr algn="l">
@@ -12751,6 +12931,7 @@
           <a:lstStyle/>
           <a:p>
             <a:pPr algn="ctr"/>
+            <a:endParaRPr/>
           </a:p>
         </p:txBody>
       </p:sp>
@@ -12811,14 +12992,11 @@
                 <a:spcPts val="300"/>
               </a:spcBef>
             </a:pPr>
-            <a:r>
-              <a:rPr sz="1100">
-                <a:solidFill>
-                  <a:srgbClr val="212121"/>
-                </a:solidFill>
-              </a:rPr>
-              <a:t/>
-            </a:r>
+            <a:endParaRPr sz="1100">
+              <a:solidFill>
+                <a:srgbClr val="212121"/>
+              </a:solidFill>
+            </a:endParaRPr>
           </a:p>
           <a:p>
             <a:pPr algn="l">
@@ -12841,14 +13019,11 @@
                 <a:spcPts val="300"/>
               </a:spcBef>
             </a:pPr>
-            <a:r>
-              <a:rPr sz="1100">
-                <a:solidFill>
-                  <a:srgbClr val="212121"/>
-                </a:solidFill>
-              </a:rPr>
-              <a:t/>
-            </a:r>
+            <a:endParaRPr sz="1100">
+              <a:solidFill>
+                <a:srgbClr val="212121"/>
+              </a:solidFill>
+            </a:endParaRPr>
           </a:p>
           <a:p>
             <a:pPr algn="l">
@@ -12886,14 +13061,11 @@
                 <a:spcPts val="300"/>
               </a:spcBef>
             </a:pPr>
-            <a:r>
-              <a:rPr sz="1100">
-                <a:solidFill>
-                  <a:srgbClr val="212121"/>
-                </a:solidFill>
-              </a:rPr>
-              <a:t/>
-            </a:r>
+            <a:endParaRPr sz="1100">
+              <a:solidFill>
+                <a:srgbClr val="212121"/>
+              </a:solidFill>
+            </a:endParaRPr>
           </a:p>
           <a:p>
             <a:pPr algn="l">
@@ -12931,14 +13103,11 @@
                 <a:spcPts val="300"/>
               </a:spcBef>
             </a:pPr>
-            <a:r>
-              <a:rPr sz="1100">
-                <a:solidFill>
-                  <a:srgbClr val="212121"/>
-                </a:solidFill>
-              </a:rPr>
-              <a:t/>
-            </a:r>
+            <a:endParaRPr sz="1100">
+              <a:solidFill>
+                <a:srgbClr val="212121"/>
+              </a:solidFill>
+            </a:endParaRPr>
           </a:p>
           <a:p>
             <a:pPr algn="l">
@@ -13012,6 +13181,7 @@
           <a:lstStyle/>
           <a:p>
             <a:pPr algn="ctr"/>
+            <a:endParaRPr/>
           </a:p>
         </p:txBody>
       </p:sp>
@@ -13102,14 +13272,11 @@
                 <a:spcPts val="300"/>
               </a:spcBef>
             </a:pPr>
-            <a:r>
-              <a:rPr sz="1100">
-                <a:solidFill>
-                  <a:srgbClr val="212121"/>
-                </a:solidFill>
-              </a:rPr>
-              <a:t/>
-            </a:r>
+            <a:endParaRPr sz="1100">
+              <a:solidFill>
+                <a:srgbClr val="212121"/>
+              </a:solidFill>
+            </a:endParaRPr>
           </a:p>
           <a:p>
             <a:pPr algn="l">
@@ -13132,14 +13299,11 @@
                 <a:spcPts val="300"/>
               </a:spcBef>
             </a:pPr>
-            <a:r>
-              <a:rPr sz="1100">
-                <a:solidFill>
-                  <a:srgbClr val="212121"/>
-                </a:solidFill>
-              </a:rPr>
-              <a:t/>
-            </a:r>
+            <a:endParaRPr sz="1100">
+              <a:solidFill>
+                <a:srgbClr val="212121"/>
+              </a:solidFill>
+            </a:endParaRPr>
           </a:p>
           <a:p>
             <a:pPr algn="l">
@@ -13162,14 +13326,11 @@
                 <a:spcPts val="300"/>
               </a:spcBef>
             </a:pPr>
-            <a:r>
-              <a:rPr sz="1100">
-                <a:solidFill>
-                  <a:srgbClr val="212121"/>
-                </a:solidFill>
-              </a:rPr>
-              <a:t/>
-            </a:r>
+            <a:endParaRPr sz="1100">
+              <a:solidFill>
+                <a:srgbClr val="212121"/>
+              </a:solidFill>
+            </a:endParaRPr>
           </a:p>
           <a:p>
             <a:pPr algn="l">
@@ -13257,7 +13418,7 @@
 </file>
 
 <file path=ppt/slides/slide6.xml><?xml version="1.0" encoding="utf-8"?>
-<p:sld xmlns:a="http://schemas.openxmlformats.org/drawingml/2006/main" xmlns:p="http://schemas.openxmlformats.org/presentationml/2006/main" xmlns:r="http://schemas.openxmlformats.org/officeDocument/2006/relationships">
+<p:sld xmlns:a="http://schemas.openxmlformats.org/drawingml/2006/main" xmlns:r="http://schemas.openxmlformats.org/officeDocument/2006/relationships" xmlns:p="http://schemas.openxmlformats.org/presentationml/2006/main">
   <p:cSld>
     <p:spTree>
       <p:nvGrpSpPr>
@@ -13265,7 +13426,14 @@
         <p:cNvGrpSpPr/>
         <p:nvPr/>
       </p:nvGrpSpPr>
-      <p:grpSpPr/>
+      <p:grpSpPr>
+        <a:xfrm>
+          <a:off x="0" y="0"/>
+          <a:ext cx="0" cy="0"/>
+          <a:chOff x="0" y="0"/>
+          <a:chExt cx="0" cy="0"/>
+        </a:xfrm>
+      </p:grpSpPr>
       <p:sp>
         <p:nvSpPr>
           <p:cNvPr id="2" name="Rectangle 1"/>
@@ -13306,6 +13474,7 @@
           <a:lstStyle/>
           <a:p>
             <a:pPr algn="ctr"/>
+            <a:endParaRPr/>
           </a:p>
         </p:txBody>
       </p:sp>
@@ -13407,6 +13576,7 @@
           <a:lstStyle/>
           <a:p>
             <a:pPr algn="ctr"/>
+            <a:endParaRPr/>
           </a:p>
         </p:txBody>
       </p:sp>
@@ -13486,14 +13656,11 @@
                 <a:spcPts val="300"/>
               </a:spcBef>
             </a:pPr>
-            <a:r>
-              <a:rPr sz="1300">
-                <a:solidFill>
-                  <a:srgbClr val="212121"/>
-                </a:solidFill>
-              </a:rPr>
-              <a:t/>
-            </a:r>
+            <a:endParaRPr sz="1300">
+              <a:solidFill>
+                <a:srgbClr val="212121"/>
+              </a:solidFill>
+            </a:endParaRPr>
           </a:p>
           <a:p>
             <a:pPr algn="l">
@@ -13561,14 +13728,11 @@
                 <a:spcPts val="300"/>
               </a:spcBef>
             </a:pPr>
-            <a:r>
-              <a:rPr sz="1300">
-                <a:solidFill>
-                  <a:srgbClr val="212121"/>
-                </a:solidFill>
-              </a:rPr>
-              <a:t/>
-            </a:r>
+            <a:endParaRPr sz="1300">
+              <a:solidFill>
+                <a:srgbClr val="212121"/>
+              </a:solidFill>
+            </a:endParaRPr>
           </a:p>
           <a:p>
             <a:pPr algn="l">
@@ -13606,14 +13770,11 @@
                 <a:spcPts val="300"/>
               </a:spcBef>
             </a:pPr>
-            <a:r>
-              <a:rPr sz="1300">
-                <a:solidFill>
-                  <a:srgbClr val="212121"/>
-                </a:solidFill>
-              </a:rPr>
-              <a:t/>
-            </a:r>
+            <a:endParaRPr sz="1300">
+              <a:solidFill>
+                <a:srgbClr val="212121"/>
+              </a:solidFill>
+            </a:endParaRPr>
           </a:p>
           <a:p>
             <a:pPr algn="l">
@@ -13666,14 +13827,11 @@
                 <a:spcPts val="300"/>
               </a:spcBef>
             </a:pPr>
-            <a:r>
-              <a:rPr sz="1300">
-                <a:solidFill>
-                  <a:srgbClr val="212121"/>
-                </a:solidFill>
-              </a:rPr>
-              <a:t/>
-            </a:r>
+            <a:endParaRPr sz="1300">
+              <a:solidFill>
+                <a:srgbClr val="212121"/>
+              </a:solidFill>
+            </a:endParaRPr>
           </a:p>
           <a:p>
             <a:pPr algn="l">
@@ -15907,7 +16065,7 @@
 </file>
 
 <file path=ppt/slides/slide7.xml><?xml version="1.0" encoding="utf-8"?>
-<p:sld xmlns:a="http://schemas.openxmlformats.org/drawingml/2006/main" xmlns:p="http://schemas.openxmlformats.org/presentationml/2006/main" xmlns:r="http://schemas.openxmlformats.org/officeDocument/2006/relationships">
+<p:sld xmlns:a="http://schemas.openxmlformats.org/drawingml/2006/main" xmlns:r="http://schemas.openxmlformats.org/officeDocument/2006/relationships" xmlns:p="http://schemas.openxmlformats.org/presentationml/2006/main">
   <p:cSld>
     <p:spTree>
       <p:nvGrpSpPr>
@@ -15915,7 +16073,14 @@
         <p:cNvGrpSpPr/>
         <p:nvPr/>
       </p:nvGrpSpPr>
-      <p:grpSpPr/>
+      <p:grpSpPr>
+        <a:xfrm>
+          <a:off x="0" y="0"/>
+          <a:ext cx="0" cy="0"/>
+          <a:chOff x="0" y="0"/>
+          <a:chExt cx="0" cy="0"/>
+        </a:xfrm>
+      </p:grpSpPr>
       <p:sp>
         <p:nvSpPr>
           <p:cNvPr id="2" name="Rectangle 1"/>
@@ -15956,6 +16121,7 @@
           <a:lstStyle/>
           <a:p>
             <a:pPr algn="ctr"/>
+            <a:endParaRPr/>
           </a:p>
         </p:txBody>
       </p:sp>
@@ -16057,6 +16223,7 @@
           <a:lstStyle/>
           <a:p>
             <a:pPr algn="ctr"/>
+            <a:endParaRPr/>
           </a:p>
         </p:txBody>
       </p:sp>
@@ -16130,7 +16297,7 @@
           </a:fontRef>
         </p:style>
         <p:txBody>
-          <a:bodyPr rtlCol="0" anchor="ctr" wrap="square"/>
+          <a:bodyPr wrap="square" rtlCol="0" anchor="ctr"/>
           <a:lstStyle/>
           <a:p>
             <a:pPr algn="l"/>
@@ -16217,14 +16384,11 @@
                 <a:spcPts val="300"/>
               </a:spcBef>
             </a:pPr>
-            <a:r>
-              <a:rPr sz="1200">
-                <a:solidFill>
-                  <a:srgbClr val="212121"/>
-                </a:solidFill>
-              </a:rPr>
-              <a:t/>
-            </a:r>
+            <a:endParaRPr sz="1200">
+              <a:solidFill>
+                <a:srgbClr val="212121"/>
+              </a:solidFill>
+            </a:endParaRPr>
           </a:p>
           <a:p>
             <a:pPr algn="l">
@@ -16262,14 +16426,11 @@
                 <a:spcPts val="300"/>
               </a:spcBef>
             </a:pPr>
-            <a:r>
-              <a:rPr sz="1200">
-                <a:solidFill>
-                  <a:srgbClr val="212121"/>
-                </a:solidFill>
-              </a:rPr>
-              <a:t/>
-            </a:r>
+            <a:endParaRPr sz="1200">
+              <a:solidFill>
+                <a:srgbClr val="212121"/>
+              </a:solidFill>
+            </a:endParaRPr>
           </a:p>
           <a:p>
             <a:pPr algn="l">
@@ -16322,14 +16483,11 @@
                 <a:spcPts val="300"/>
               </a:spcBef>
             </a:pPr>
-            <a:r>
-              <a:rPr sz="1200">
-                <a:solidFill>
-                  <a:srgbClr val="212121"/>
-                </a:solidFill>
-              </a:rPr>
-              <a:t/>
-            </a:r>
+            <a:endParaRPr sz="1200">
+              <a:solidFill>
+                <a:srgbClr val="212121"/>
+              </a:solidFill>
+            </a:endParaRPr>
           </a:p>
           <a:p>
             <a:pPr algn="l">
@@ -16367,14 +16525,11 @@
                 <a:spcPts val="300"/>
               </a:spcBef>
             </a:pPr>
-            <a:r>
-              <a:rPr sz="1200">
-                <a:solidFill>
-                  <a:srgbClr val="212121"/>
-                </a:solidFill>
-              </a:rPr>
-              <a:t/>
-            </a:r>
+            <a:endParaRPr sz="1200">
+              <a:solidFill>
+                <a:srgbClr val="212121"/>
+              </a:solidFill>
+            </a:endParaRPr>
           </a:p>
           <a:p>
             <a:pPr algn="l">
@@ -16417,7 +16572,7 @@
 </file>
 
 <file path=ppt/slides/slide8.xml><?xml version="1.0" encoding="utf-8"?>
-<p:sld xmlns:a="http://schemas.openxmlformats.org/drawingml/2006/main" xmlns:p="http://schemas.openxmlformats.org/presentationml/2006/main" xmlns:r="http://schemas.openxmlformats.org/officeDocument/2006/relationships">
+<p:sld xmlns:a="http://schemas.openxmlformats.org/drawingml/2006/main" xmlns:r="http://schemas.openxmlformats.org/officeDocument/2006/relationships" xmlns:p="http://schemas.openxmlformats.org/presentationml/2006/main">
   <p:cSld>
     <p:spTree>
       <p:nvGrpSpPr>
@@ -16425,7 +16580,14 @@
         <p:cNvGrpSpPr/>
         <p:nvPr/>
       </p:nvGrpSpPr>
-      <p:grpSpPr/>
+      <p:grpSpPr>
+        <a:xfrm>
+          <a:off x="0" y="0"/>
+          <a:ext cx="0" cy="0"/>
+          <a:chOff x="0" y="0"/>
+          <a:chExt cx="0" cy="0"/>
+        </a:xfrm>
+      </p:grpSpPr>
       <p:sp>
         <p:nvSpPr>
           <p:cNvPr id="2" name="Rectangle 1"/>
@@ -16466,6 +16628,7 @@
           <a:lstStyle/>
           <a:p>
             <a:pPr algn="ctr"/>
+            <a:endParaRPr/>
           </a:p>
         </p:txBody>
       </p:sp>
@@ -16567,6 +16730,7 @@
           <a:lstStyle/>
           <a:p>
             <a:pPr algn="ctr"/>
+            <a:endParaRPr/>
           </a:p>
         </p:txBody>
       </p:sp>
@@ -17004,7 +17168,7 @@
 </file>
 
 <file path=ppt/slides/slide9.xml><?xml version="1.0" encoding="utf-8"?>
-<p:sld xmlns:a="http://schemas.openxmlformats.org/drawingml/2006/main" xmlns:p="http://schemas.openxmlformats.org/presentationml/2006/main" xmlns:r="http://schemas.openxmlformats.org/officeDocument/2006/relationships">
+<p:sld xmlns:a="http://schemas.openxmlformats.org/drawingml/2006/main" xmlns:r="http://schemas.openxmlformats.org/officeDocument/2006/relationships" xmlns:p="http://schemas.openxmlformats.org/presentationml/2006/main">
   <p:cSld>
     <p:spTree>
       <p:nvGrpSpPr>
@@ -17012,7 +17176,14 @@
         <p:cNvGrpSpPr/>
         <p:nvPr/>
       </p:nvGrpSpPr>
-      <p:grpSpPr/>
+      <p:grpSpPr>
+        <a:xfrm>
+          <a:off x="0" y="0"/>
+          <a:ext cx="0" cy="0"/>
+          <a:chOff x="0" y="0"/>
+          <a:chExt cx="0" cy="0"/>
+        </a:xfrm>
+      </p:grpSpPr>
       <p:sp>
         <p:nvSpPr>
           <p:cNvPr id="2" name="Rectangle 1"/>
@@ -17053,6 +17224,7 @@
           <a:lstStyle/>
           <a:p>
             <a:pPr algn="ctr"/>
+            <a:endParaRPr/>
           </a:p>
         </p:txBody>
       </p:sp>
@@ -17154,6 +17326,7 @@
           <a:lstStyle/>
           <a:p>
             <a:pPr algn="ctr"/>
+            <a:endParaRPr/>
           </a:p>
         </p:txBody>
       </p:sp>
@@ -17199,8 +17372,8 @@
         </p:nvSpPr>
         <p:spPr>
           <a:xfrm>
-            <a:off x="411480" y="1143000"/>
-            <a:ext cx="6400800" cy="5349240"/>
+            <a:off x="411480" y="1293800"/>
+            <a:ext cx="5477256" cy="4270400"/>
           </a:xfrm>
           <a:prstGeom prst="rect">
             <a:avLst/>
@@ -17219,12 +17392,28 @@
               </a:spcBef>
             </a:pPr>
             <a:r>
-              <a:rPr sz="1300">
-                <a:solidFill>
-                  <a:srgbClr val="212121"/>
-                </a:solidFill>
-              </a:rPr>
-              <a:t>O problema:</a:t>
+              <a:rPr sz="1300" dirty="0">
+                <a:solidFill>
+                  <a:srgbClr val="212121"/>
+                </a:solidFill>
+              </a:rPr>
+              <a:t>O </a:t>
+            </a:r>
+            <a:r>
+              <a:rPr sz="1300" dirty="0" err="1">
+                <a:solidFill>
+                  <a:srgbClr val="212121"/>
+                </a:solidFill>
+              </a:rPr>
+              <a:t>problema</a:t>
+            </a:r>
+            <a:r>
+              <a:rPr sz="1300" dirty="0">
+                <a:solidFill>
+                  <a:srgbClr val="212121"/>
+                </a:solidFill>
+              </a:rPr>
+              <a:t>:</a:t>
             </a:r>
           </a:p>
           <a:p>
@@ -17234,12 +17423,60 @@
               </a:spcBef>
             </a:pPr>
             <a:r>
-              <a:rPr sz="1300">
-                <a:solidFill>
-                  <a:srgbClr val="212121"/>
-                </a:solidFill>
-              </a:rPr>
-              <a:t>   DefuzzyLayer produz ŷ ∈ ℝ  →  sigmoid  →  P(doença) ∈ [0,1].</a:t>
+              <a:rPr sz="1300" dirty="0">
+                <a:solidFill>
+                  <a:srgbClr val="212121"/>
+                </a:solidFill>
+              </a:rPr>
+              <a:t>   </a:t>
+            </a:r>
+            <a:r>
+              <a:rPr sz="1300" dirty="0" err="1">
+                <a:solidFill>
+                  <a:srgbClr val="212121"/>
+                </a:solidFill>
+              </a:rPr>
+              <a:t>DefuzzyLayer</a:t>
+            </a:r>
+            <a:r>
+              <a:rPr sz="1300" dirty="0">
+                <a:solidFill>
+                  <a:srgbClr val="212121"/>
+                </a:solidFill>
+              </a:rPr>
+              <a:t> </a:t>
+            </a:r>
+            <a:r>
+              <a:rPr sz="1300" dirty="0" err="1">
+                <a:solidFill>
+                  <a:srgbClr val="212121"/>
+                </a:solidFill>
+              </a:rPr>
+              <a:t>produz</a:t>
+            </a:r>
+            <a:r>
+              <a:rPr sz="1300" dirty="0">
+                <a:solidFill>
+                  <a:srgbClr val="212121"/>
+                </a:solidFill>
+              </a:rPr>
+              <a:t> ŷ ∈ ℝ  →  sigmoid  →  P(</a:t>
+            </a:r>
+            <a:r>
+              <a:rPr sz="1300" dirty="0" err="1">
+                <a:solidFill>
+                  <a:srgbClr val="212121"/>
+                </a:solidFill>
+              </a:rPr>
+              <a:t>doença</a:t>
+            </a:r>
+            <a:r>
+              <a:rPr sz="1300" dirty="0">
+                <a:solidFill>
+                  <a:srgbClr val="212121"/>
+                </a:solidFill>
+              </a:rPr>
+              <a:t>) ∈ [0,1].</a:t>
             </a:r>
           </a:p>
           <a:p>
@@ -17249,12 +17486,156 @@
               </a:spcBef>
             </a:pPr>
             <a:r>
-              <a:rPr sz="1300">
-                <a:solidFill>
-                  <a:srgbClr val="212121"/>
-                </a:solidFill>
-              </a:rPr>
-              <a:t>   Regras Takagi-Sugeno não têm consequente linguístico, apenas um número c_k.</a:t>
+              <a:rPr sz="1300" dirty="0">
+                <a:solidFill>
+                  <a:srgbClr val="212121"/>
+                </a:solidFill>
+              </a:rPr>
+              <a:t>   </a:t>
+            </a:r>
+            <a:r>
+              <a:rPr sz="1300" dirty="0" err="1">
+                <a:solidFill>
+                  <a:srgbClr val="212121"/>
+                </a:solidFill>
+              </a:rPr>
+              <a:t>Regras</a:t>
+            </a:r>
+            <a:r>
+              <a:rPr sz="1300" dirty="0">
+                <a:solidFill>
+                  <a:srgbClr val="212121"/>
+                </a:solidFill>
+              </a:rPr>
+              <a:t> Takagi-</a:t>
+            </a:r>
+            <a:r>
+              <a:rPr sz="1300" dirty="0" err="1">
+                <a:solidFill>
+                  <a:srgbClr val="212121"/>
+                </a:solidFill>
+              </a:rPr>
+              <a:t>Sugeno</a:t>
+            </a:r>
+            <a:r>
+              <a:rPr sz="1300" dirty="0">
+                <a:solidFill>
+                  <a:srgbClr val="212121"/>
+                </a:solidFill>
+              </a:rPr>
+              <a:t> </a:t>
+            </a:r>
+            <a:r>
+              <a:rPr sz="1300" dirty="0" err="1">
+                <a:solidFill>
+                  <a:srgbClr val="212121"/>
+                </a:solidFill>
+              </a:rPr>
+              <a:t>não</a:t>
+            </a:r>
+            <a:r>
+              <a:rPr sz="1300" dirty="0">
+                <a:solidFill>
+                  <a:srgbClr val="212121"/>
+                </a:solidFill>
+              </a:rPr>
+              <a:t> </a:t>
+            </a:r>
+            <a:r>
+              <a:rPr sz="1300" dirty="0" err="1">
+                <a:solidFill>
+                  <a:srgbClr val="212121"/>
+                </a:solidFill>
+              </a:rPr>
+              <a:t>têm</a:t>
+            </a:r>
+            <a:r>
+              <a:rPr sz="1300" dirty="0">
+                <a:solidFill>
+                  <a:srgbClr val="212121"/>
+                </a:solidFill>
+              </a:rPr>
+              <a:t> </a:t>
+            </a:r>
+            <a:r>
+              <a:rPr sz="1300" dirty="0" err="1">
+                <a:solidFill>
+                  <a:srgbClr val="212121"/>
+                </a:solidFill>
+              </a:rPr>
+              <a:t>consequente</a:t>
+            </a:r>
+            <a:r>
+              <a:rPr sz="1300" dirty="0">
+                <a:solidFill>
+                  <a:srgbClr val="212121"/>
+                </a:solidFill>
+              </a:rPr>
+              <a:t> </a:t>
+            </a:r>
+            <a:r>
+              <a:rPr sz="1300" dirty="0" err="1">
+                <a:solidFill>
+                  <a:srgbClr val="212121"/>
+                </a:solidFill>
+              </a:rPr>
+              <a:t>linguístico</a:t>
+            </a:r>
+            <a:r>
+              <a:rPr sz="1300" dirty="0">
+                <a:solidFill>
+                  <a:srgbClr val="212121"/>
+                </a:solidFill>
+              </a:rPr>
+              <a:t>, </a:t>
+            </a:r>
+            <a:r>
+              <a:rPr sz="1300" dirty="0" err="1">
+                <a:solidFill>
+                  <a:srgbClr val="212121"/>
+                </a:solidFill>
+              </a:rPr>
+              <a:t>apenas</a:t>
+            </a:r>
+            <a:r>
+              <a:rPr sz="1300" dirty="0">
+                <a:solidFill>
+                  <a:srgbClr val="212121"/>
+                </a:solidFill>
+              </a:rPr>
+              <a:t> um </a:t>
+            </a:r>
+            <a:r>
+              <a:rPr sz="1300" dirty="0" err="1">
+                <a:solidFill>
+                  <a:srgbClr val="212121"/>
+                </a:solidFill>
+              </a:rPr>
+              <a:t>número</a:t>
+            </a:r>
+            <a:r>
+              <a:rPr sz="1300" dirty="0">
+                <a:solidFill>
+                  <a:srgbClr val="212121"/>
+                </a:solidFill>
+              </a:rPr>
+              <a:t> </a:t>
+            </a:r>
+            <a:r>
+              <a:rPr sz="1300" dirty="0" err="1">
+                <a:solidFill>
+                  <a:srgbClr val="212121"/>
+                </a:solidFill>
+              </a:rPr>
+              <a:t>c_k</a:t>
+            </a:r>
+            <a:r>
+              <a:rPr sz="1300" dirty="0">
+                <a:solidFill>
+                  <a:srgbClr val="212121"/>
+                </a:solidFill>
+              </a:rPr>
+              <a:t>.</a:t>
             </a:r>
           </a:p>
           <a:p>
@@ -17264,12 +17645,76 @@
               </a:spcBef>
             </a:pPr>
             <a:r>
-              <a:rPr sz="1300">
-                <a:solidFill>
-                  <a:srgbClr val="212121"/>
-                </a:solidFill>
-              </a:rPr>
-              <a:t>   Para transcrever "SE ... ENTÃO risco = ALTO" precisamos mapear ŷ a um label.</a:t>
+              <a:rPr sz="1300" dirty="0">
+                <a:solidFill>
+                  <a:srgbClr val="212121"/>
+                </a:solidFill>
+              </a:rPr>
+              <a:t>   Para </a:t>
+            </a:r>
+            <a:r>
+              <a:rPr sz="1300" dirty="0" err="1">
+                <a:solidFill>
+                  <a:srgbClr val="212121"/>
+                </a:solidFill>
+              </a:rPr>
+              <a:t>transcrever</a:t>
+            </a:r>
+            <a:r>
+              <a:rPr sz="1300" dirty="0">
+                <a:solidFill>
+                  <a:srgbClr val="212121"/>
+                </a:solidFill>
+              </a:rPr>
+              <a:t> "SE ... ENTÃO </a:t>
+            </a:r>
+            <a:r>
+              <a:rPr sz="1300" dirty="0" err="1">
+                <a:solidFill>
+                  <a:srgbClr val="212121"/>
+                </a:solidFill>
+              </a:rPr>
+              <a:t>risco</a:t>
+            </a:r>
+            <a:r>
+              <a:rPr sz="1300" dirty="0">
+                <a:solidFill>
+                  <a:srgbClr val="212121"/>
+                </a:solidFill>
+              </a:rPr>
+              <a:t> = ALTO" </a:t>
+            </a:r>
+            <a:r>
+              <a:rPr sz="1300" dirty="0" err="1">
+                <a:solidFill>
+                  <a:srgbClr val="212121"/>
+                </a:solidFill>
+              </a:rPr>
+              <a:t>precisamos</a:t>
+            </a:r>
+            <a:r>
+              <a:rPr sz="1300" dirty="0">
+                <a:solidFill>
+                  <a:srgbClr val="212121"/>
+                </a:solidFill>
+              </a:rPr>
+              <a:t> </a:t>
+            </a:r>
+            <a:r>
+              <a:rPr sz="1300" dirty="0" err="1">
+                <a:solidFill>
+                  <a:srgbClr val="212121"/>
+                </a:solidFill>
+              </a:rPr>
+              <a:t>mapear</a:t>
+            </a:r>
+            <a:r>
+              <a:rPr sz="1300" dirty="0">
+                <a:solidFill>
+                  <a:srgbClr val="212121"/>
+                </a:solidFill>
+              </a:rPr>
+              <a:t> ŷ a um label.</a:t>
             </a:r>
           </a:p>
           <a:p>
@@ -17278,14 +17723,11 @@
                 <a:spcPts val="300"/>
               </a:spcBef>
             </a:pPr>
-            <a:r>
-              <a:rPr sz="1300">
-                <a:solidFill>
-                  <a:srgbClr val="212121"/>
-                </a:solidFill>
-              </a:rPr>
-              <a:t/>
-            </a:r>
+            <a:endParaRPr sz="1300" dirty="0">
+              <a:solidFill>
+                <a:srgbClr val="212121"/>
+              </a:solidFill>
+            </a:endParaRPr>
           </a:p>
           <a:p>
             <a:pPr algn="l">
@@ -17294,12 +17736,60 @@
               </a:spcBef>
             </a:pPr>
             <a:r>
-              <a:rPr sz="1300">
-                <a:solidFill>
-                  <a:srgbClr val="212121"/>
-                </a:solidFill>
-              </a:rPr>
-              <a:t>A solução (definição analítica manual):</a:t>
+              <a:rPr sz="1300" dirty="0">
+                <a:solidFill>
+                  <a:srgbClr val="212121"/>
+                </a:solidFill>
+              </a:rPr>
+              <a:t>A </a:t>
+            </a:r>
+            <a:r>
+              <a:rPr sz="1300" dirty="0" err="1">
+                <a:solidFill>
+                  <a:srgbClr val="212121"/>
+                </a:solidFill>
+              </a:rPr>
+              <a:t>solução</a:t>
+            </a:r>
+            <a:r>
+              <a:rPr sz="1300" dirty="0">
+                <a:solidFill>
+                  <a:srgbClr val="212121"/>
+                </a:solidFill>
+              </a:rPr>
+              <a:t> (</a:t>
+            </a:r>
+            <a:r>
+              <a:rPr sz="1300" dirty="0" err="1">
+                <a:solidFill>
+                  <a:srgbClr val="212121"/>
+                </a:solidFill>
+              </a:rPr>
+              <a:t>definição</a:t>
+            </a:r>
+            <a:r>
+              <a:rPr sz="1300" dirty="0">
+                <a:solidFill>
+                  <a:srgbClr val="212121"/>
+                </a:solidFill>
+              </a:rPr>
+              <a:t> </a:t>
+            </a:r>
+            <a:r>
+              <a:rPr sz="1300" dirty="0" err="1">
+                <a:solidFill>
+                  <a:srgbClr val="212121"/>
+                </a:solidFill>
+              </a:rPr>
+              <a:t>analítica</a:t>
+            </a:r>
+            <a:r>
+              <a:rPr sz="1300" dirty="0">
+                <a:solidFill>
+                  <a:srgbClr val="212121"/>
+                </a:solidFill>
+              </a:rPr>
+              <a:t> manual):</a:t>
             </a:r>
           </a:p>
           <a:p>
@@ -17309,12 +17799,76 @@
               </a:spcBef>
             </a:pPr>
             <a:r>
-              <a:rPr sz="1300">
-                <a:solidFill>
-                  <a:srgbClr val="212121"/>
-                </a:solidFill>
-              </a:rPr>
-              <a:t>   5 MFs triangulares uniformemente espaçadas em [0, 1]:</a:t>
+              <a:rPr sz="1300" dirty="0">
+                <a:solidFill>
+                  <a:srgbClr val="212121"/>
+                </a:solidFill>
+              </a:rPr>
+              <a:t>   5 MFs </a:t>
+            </a:r>
+            <a:r>
+              <a:rPr sz="1300" dirty="0" err="1">
+                <a:solidFill>
+                  <a:srgbClr val="212121"/>
+                </a:solidFill>
+              </a:rPr>
+              <a:t>triangulares</a:t>
+            </a:r>
+            <a:r>
+              <a:rPr sz="1300" dirty="0">
+                <a:solidFill>
+                  <a:srgbClr val="212121"/>
+                </a:solidFill>
+              </a:rPr>
+              <a:t> </a:t>
+            </a:r>
+            <a:r>
+              <a:rPr sz="1300" dirty="0" err="1">
+                <a:solidFill>
+                  <a:srgbClr val="212121"/>
+                </a:solidFill>
+              </a:rPr>
+              <a:t>uniformemente</a:t>
+            </a:r>
+            <a:r>
+              <a:rPr sz="1300" dirty="0">
+                <a:solidFill>
+                  <a:srgbClr val="212121"/>
+                </a:solidFill>
+              </a:rPr>
+              <a:t> </a:t>
+            </a:r>
+            <a:r>
+              <a:rPr sz="1300" dirty="0" err="1">
+                <a:solidFill>
+                  <a:srgbClr val="212121"/>
+                </a:solidFill>
+              </a:rPr>
+              <a:t>espaçadas</a:t>
+            </a:r>
+            <a:r>
+              <a:rPr sz="1300" dirty="0">
+                <a:solidFill>
+                  <a:srgbClr val="212121"/>
+                </a:solidFill>
+              </a:rPr>
+              <a:t> </a:t>
+            </a:r>
+            <a:r>
+              <a:rPr sz="1300" dirty="0" err="1">
+                <a:solidFill>
+                  <a:srgbClr val="212121"/>
+                </a:solidFill>
+              </a:rPr>
+              <a:t>em</a:t>
+            </a:r>
+            <a:r>
+              <a:rPr sz="1300" dirty="0">
+                <a:solidFill>
+                  <a:srgbClr val="212121"/>
+                </a:solidFill>
+              </a:rPr>
+              <a:t> [0, 1]:</a:t>
             </a:r>
           </a:p>
           <a:p>
@@ -17324,12 +17878,28 @@
               </a:spcBef>
             </a:pPr>
             <a:r>
-              <a:rPr sz="1300">
-                <a:solidFill>
-                  <a:srgbClr val="212121"/>
-                </a:solidFill>
-              </a:rPr>
-              <a:t>   centros  c = [1/6, 2/6, 3/6, 4/6, 5/6]</a:t>
+              <a:rPr sz="1300" dirty="0">
+                <a:solidFill>
+                  <a:srgbClr val="212121"/>
+                </a:solidFill>
+              </a:rPr>
+              <a:t>   </a:t>
+            </a:r>
+            <a:r>
+              <a:rPr sz="1300" dirty="0" err="1">
+                <a:solidFill>
+                  <a:srgbClr val="212121"/>
+                </a:solidFill>
+              </a:rPr>
+              <a:t>centros</a:t>
+            </a:r>
+            <a:r>
+              <a:rPr sz="1300" dirty="0">
+                <a:solidFill>
+                  <a:srgbClr val="212121"/>
+                </a:solidFill>
+              </a:rPr>
+              <a:t>  c = [1/6, 2/6, 3/6, 4/6, 5/6]</a:t>
             </a:r>
           </a:p>
           <a:p>
@@ -17339,13 +17909,106 @@
               </a:spcBef>
             </a:pPr>
             <a:r>
-              <a:rPr sz="1300">
-                <a:solidFill>
-                  <a:srgbClr val="212121"/>
-                </a:solidFill>
-              </a:rPr>
-              <a:t>   meia-largura  hw = 1/6  →  partição exata, sem sobreposição</a:t>
-            </a:r>
+              <a:rPr sz="1300" dirty="0">
+                <a:solidFill>
+                  <a:srgbClr val="212121"/>
+                </a:solidFill>
+              </a:rPr>
+              <a:t>   </a:t>
+            </a:r>
+            <a:r>
+              <a:rPr sz="1300" dirty="0" err="1">
+                <a:solidFill>
+                  <a:srgbClr val="212121"/>
+                </a:solidFill>
+              </a:rPr>
+              <a:t>meia-largura</a:t>
+            </a:r>
+            <a:r>
+              <a:rPr sz="1300" dirty="0">
+                <a:solidFill>
+                  <a:srgbClr val="212121"/>
+                </a:solidFill>
+              </a:rPr>
+              <a:t>  </a:t>
+            </a:r>
+            <a:r>
+              <a:rPr sz="1300" dirty="0" err="1">
+                <a:solidFill>
+                  <a:srgbClr val="212121"/>
+                </a:solidFill>
+              </a:rPr>
+              <a:t>hw</a:t>
+            </a:r>
+            <a:r>
+              <a:rPr sz="1300" dirty="0">
+                <a:solidFill>
+                  <a:srgbClr val="212121"/>
+                </a:solidFill>
+              </a:rPr>
+              <a:t> = 1/6  →  </a:t>
+            </a:r>
+            <a:r>
+              <a:rPr sz="1300" dirty="0" err="1">
+                <a:solidFill>
+                  <a:srgbClr val="212121"/>
+                </a:solidFill>
+              </a:rPr>
+              <a:t>partição</a:t>
+            </a:r>
+            <a:r>
+              <a:rPr sz="1300" dirty="0">
+                <a:solidFill>
+                  <a:srgbClr val="212121"/>
+                </a:solidFill>
+              </a:rPr>
+              <a:t> </a:t>
+            </a:r>
+            <a:r>
+              <a:rPr sz="1300" dirty="0" err="1">
+                <a:solidFill>
+                  <a:srgbClr val="212121"/>
+                </a:solidFill>
+              </a:rPr>
+              <a:t>exata</a:t>
+            </a:r>
+            <a:r>
+              <a:rPr sz="1300" dirty="0">
+                <a:solidFill>
+                  <a:srgbClr val="212121"/>
+                </a:solidFill>
+              </a:rPr>
+              <a:t>, </a:t>
+            </a:r>
+            <a:r>
+              <a:rPr sz="1300" dirty="0" err="1">
+                <a:solidFill>
+                  <a:srgbClr val="212121"/>
+                </a:solidFill>
+              </a:rPr>
+              <a:t>sem</a:t>
+            </a:r>
+            <a:r>
+              <a:rPr sz="1300" dirty="0">
+                <a:solidFill>
+                  <a:srgbClr val="212121"/>
+                </a:solidFill>
+              </a:rPr>
+              <a:t> </a:t>
+            </a:r>
+            <a:r>
+              <a:rPr sz="1300" dirty="0" err="1">
+                <a:solidFill>
+                  <a:srgbClr val="212121"/>
+                </a:solidFill>
+              </a:rPr>
+              <a:t>sobreposição</a:t>
+            </a:r>
+            <a:endParaRPr sz="1300" dirty="0">
+              <a:solidFill>
+                <a:srgbClr val="212121"/>
+              </a:solidFill>
+            </a:endParaRPr>
           </a:p>
           <a:p>
             <a:pPr algn="l">
@@ -17353,14 +18016,11 @@
                 <a:spcPts val="300"/>
               </a:spcBef>
             </a:pPr>
-            <a:r>
-              <a:rPr sz="1300">
-                <a:solidFill>
-                  <a:srgbClr val="212121"/>
-                </a:solidFill>
-              </a:rPr>
-              <a:t/>
-            </a:r>
+            <a:endParaRPr sz="1300" dirty="0">
+              <a:solidFill>
+                <a:srgbClr val="212121"/>
+              </a:solidFill>
+            </a:endParaRPr>
           </a:p>
           <a:p>
             <a:pPr algn="l">
@@ -17369,12 +18029,28 @@
               </a:spcBef>
             </a:pPr>
             <a:r>
-              <a:rPr sz="1300">
-                <a:solidFill>
-                  <a:srgbClr val="212121"/>
-                </a:solidFill>
-              </a:rPr>
-              <a:t>   μⱼ(ŷ) = max(0,  1 − |ŷ − cⱼ| / hw)</a:t>
+              <a:rPr sz="1300" dirty="0">
+                <a:solidFill>
+                  <a:srgbClr val="212121"/>
+                </a:solidFill>
+              </a:rPr>
+              <a:t>   μⱼ(ŷ) = max(0,  1 − |ŷ − cⱼ| / </a:t>
+            </a:r>
+            <a:r>
+              <a:rPr sz="1300" dirty="0" err="1">
+                <a:solidFill>
+                  <a:srgbClr val="212121"/>
+                </a:solidFill>
+              </a:rPr>
+              <a:t>hw</a:t>
+            </a:r>
+            <a:r>
+              <a:rPr sz="1300" dirty="0">
+                <a:solidFill>
+                  <a:srgbClr val="212121"/>
+                </a:solidFill>
+              </a:rPr>
+              <a:t>)</a:t>
             </a:r>
           </a:p>
           <a:p>
@@ -17384,12 +18060,28 @@
               </a:spcBef>
             </a:pPr>
             <a:r>
-              <a:rPr sz="1300">
-                <a:solidFill>
-                  <a:srgbClr val="212121"/>
-                </a:solidFill>
-              </a:rPr>
-              <a:t>   rótulo(ŷ) = argmaxⱼ μⱼ(ŷ)</a:t>
+              <a:rPr sz="1300" dirty="0">
+                <a:solidFill>
+                  <a:srgbClr val="212121"/>
+                </a:solidFill>
+              </a:rPr>
+              <a:t>   </a:t>
+            </a:r>
+            <a:r>
+              <a:rPr sz="1300" dirty="0" err="1">
+                <a:solidFill>
+                  <a:srgbClr val="212121"/>
+                </a:solidFill>
+              </a:rPr>
+              <a:t>rótulo</a:t>
+            </a:r>
+            <a:r>
+              <a:rPr sz="1300" dirty="0">
+                <a:solidFill>
+                  <a:srgbClr val="212121"/>
+                </a:solidFill>
+              </a:rPr>
+              <a:t>(ŷ) = argmaxⱼ μⱼ(ŷ)</a:t>
             </a:r>
           </a:p>
           <a:p>
@@ -17398,14 +18090,11 @@
                 <a:spcPts val="300"/>
               </a:spcBef>
             </a:pPr>
-            <a:r>
-              <a:rPr sz="1300">
-                <a:solidFill>
-                  <a:srgbClr val="212121"/>
-                </a:solidFill>
-              </a:rPr>
-              <a:t/>
-            </a:r>
+            <a:endParaRPr sz="1300" dirty="0">
+              <a:solidFill>
+                <a:srgbClr val="212121"/>
+              </a:solidFill>
+            </a:endParaRPr>
           </a:p>
           <a:p>
             <a:pPr algn="l">
@@ -17414,12 +18103,76 @@
               </a:spcBef>
             </a:pPr>
             <a:r>
-              <a:rPr sz="1300">
-                <a:solidFill>
-                  <a:srgbClr val="212121"/>
-                </a:solidFill>
-              </a:rPr>
-              <a:t>   Labels: baixo | baixo_médio | médio | médio_alto | alto</a:t>
+              <a:rPr sz="1300" dirty="0">
+                <a:solidFill>
+                  <a:srgbClr val="212121"/>
+                </a:solidFill>
+              </a:rPr>
+              <a:t>   Labels: </a:t>
+            </a:r>
+            <a:r>
+              <a:rPr sz="1300" dirty="0" err="1">
+                <a:solidFill>
+                  <a:srgbClr val="212121"/>
+                </a:solidFill>
+              </a:rPr>
+              <a:t>baixo</a:t>
+            </a:r>
+            <a:r>
+              <a:rPr sz="1300" dirty="0">
+                <a:solidFill>
+                  <a:srgbClr val="212121"/>
+                </a:solidFill>
+              </a:rPr>
+              <a:t> | </a:t>
+            </a:r>
+            <a:r>
+              <a:rPr sz="1300" dirty="0" err="1">
+                <a:solidFill>
+                  <a:srgbClr val="212121"/>
+                </a:solidFill>
+              </a:rPr>
+              <a:t>baixo_médio</a:t>
+            </a:r>
+            <a:r>
+              <a:rPr sz="1300" dirty="0">
+                <a:solidFill>
+                  <a:srgbClr val="212121"/>
+                </a:solidFill>
+              </a:rPr>
+              <a:t> | </a:t>
+            </a:r>
+            <a:r>
+              <a:rPr sz="1300" dirty="0" err="1">
+                <a:solidFill>
+                  <a:srgbClr val="212121"/>
+                </a:solidFill>
+              </a:rPr>
+              <a:t>médio</a:t>
+            </a:r>
+            <a:r>
+              <a:rPr sz="1300" dirty="0">
+                <a:solidFill>
+                  <a:srgbClr val="212121"/>
+                </a:solidFill>
+              </a:rPr>
+              <a:t> | </a:t>
+            </a:r>
+            <a:r>
+              <a:rPr sz="1300" dirty="0" err="1">
+                <a:solidFill>
+                  <a:srgbClr val="212121"/>
+                </a:solidFill>
+              </a:rPr>
+              <a:t>médio_alto</a:t>
+            </a:r>
+            <a:r>
+              <a:rPr sz="1300" dirty="0">
+                <a:solidFill>
+                  <a:srgbClr val="212121"/>
+                </a:solidFill>
+              </a:rPr>
+              <a:t> | alto</a:t>
             </a:r>
           </a:p>
           <a:p>
@@ -17428,14 +18181,11 @@
                 <a:spcPts val="300"/>
               </a:spcBef>
             </a:pPr>
-            <a:r>
-              <a:rPr sz="1300">
-                <a:solidFill>
-                  <a:srgbClr val="212121"/>
-                </a:solidFill>
-              </a:rPr>
-              <a:t/>
-            </a:r>
+            <a:endParaRPr sz="1300" dirty="0">
+              <a:solidFill>
+                <a:srgbClr val="212121"/>
+              </a:solidFill>
+            </a:endParaRPr>
           </a:p>
           <a:p>
             <a:pPr algn="l">
@@ -17444,12 +18194,28 @@
               </a:spcBef>
             </a:pPr>
             <a:r>
-              <a:rPr sz="1300">
-                <a:solidFill>
-                  <a:srgbClr val="212121"/>
-                </a:solidFill>
-              </a:rPr>
-              <a:t>   Ex.: ŷ = 0,78  →  μ₄(alto) = 0,68  →  risco = alto</a:t>
+              <a:rPr sz="1300" dirty="0">
+                <a:solidFill>
+                  <a:srgbClr val="212121"/>
+                </a:solidFill>
+              </a:rPr>
+              <a:t>   Ex.: ŷ = 0,78  →  μ₄(alto) = 0,68  →  </a:t>
+            </a:r>
+            <a:r>
+              <a:rPr sz="1300" dirty="0" err="1">
+                <a:solidFill>
+                  <a:srgbClr val="212121"/>
+                </a:solidFill>
+              </a:rPr>
+              <a:t>risco</a:t>
+            </a:r>
+            <a:r>
+              <a:rPr sz="1300" dirty="0">
+                <a:solidFill>
+                  <a:srgbClr val="212121"/>
+                </a:solidFill>
+              </a:rPr>
+              <a:t> = alto</a:t>
             </a:r>
           </a:p>
         </p:txBody>
@@ -17470,8 +18236,8 @@
         </p:blipFill>
         <p:spPr>
           <a:xfrm>
-            <a:off x="6583680" y="1143000"/>
-            <a:ext cx="5303520" cy="5212080"/>
+            <a:off x="5888736" y="1143000"/>
+            <a:ext cx="5998464" cy="5212080"/>
           </a:xfrm>
           <a:prstGeom prst="rect">
             <a:avLst/>

</xml_diff>